<commit_message>
File outstanding working-tree artifacts and delete strays
</commit_message>
<xml_diff>
--- a/docs/report/Theta_Pen_Plotter_Summer_Progress_Update.pptx
+++ b/docs/report/Theta_Pen_Plotter_Summer_Progress_Update.pptx
@@ -2371,8 +2371,8 @@
         </p:nvSpPr>
         <p:spPr>
           <a:xfrm>
-            <a:off x="964194" y="4983933"/>
-            <a:ext cx="4617267" cy="570368"/>
+            <a:off x="964194" y="4832350"/>
+            <a:ext cx="4617267" cy="625475"/>
           </a:xfrm>
           <a:prstGeom prst="rect">
             <a:avLst/>
@@ -2968,6 +2968,381 @@
 Release, then make a bounded clearance pulse.
 Abort
 Fail to touch, release, or clear.</a:t>
+            </a:r>
+          </a:p>
+        </p:txBody>
+      </p:sp>
+      <p:cxnSp>
+        <p:nvCxnSpPr>
+          <p:cNvPr id="2" name="Straight Arrow Connector 1">
+            <a:extLst>
+              <a:ext uri="{FF2B5EF4-FFF2-40B4-BE49-F238E27FC236}">
+                <a16:creationId xmlns:a16="http://schemas.microsoft.com/office/drawing/2014/main" id="{1EBB5AAE-5BDC-2AA2-97E5-38E7F7F97585}"/>
+              </a:ext>
+            </a:extLst>
+          </p:cNvPr>
+          <p:cNvCxnSpPr>
+            <a:cxnSpLocks/>
+          </p:cNvCxnSpPr>
+          <p:nvPr/>
+        </p:nvCxnSpPr>
+        <p:spPr>
+          <a:xfrm>
+            <a:off x="357051" y="2386149"/>
+            <a:ext cx="452846" cy="329891"/>
+          </a:xfrm>
+          <a:prstGeom prst="straightConnector1">
+            <a:avLst/>
+          </a:prstGeom>
+          <a:ln>
+            <a:solidFill>
+              <a:schemeClr val="bg1"/>
+            </a:solidFill>
+            <a:tailEnd type="triangle"/>
+          </a:ln>
+        </p:spPr>
+        <p:style>
+          <a:lnRef idx="1">
+            <a:schemeClr val="accent1"/>
+          </a:lnRef>
+          <a:fillRef idx="0">
+            <a:schemeClr val="accent1"/>
+          </a:fillRef>
+          <a:effectRef idx="0">
+            <a:schemeClr val="accent1"/>
+          </a:effectRef>
+          <a:fontRef idx="minor">
+            <a:schemeClr val="tx1"/>
+          </a:fontRef>
+        </p:style>
+      </p:cxnSp>
+      <p:cxnSp>
+        <p:nvCxnSpPr>
+          <p:cNvPr id="3" name="Straight Arrow Connector 2">
+            <a:extLst>
+              <a:ext uri="{FF2B5EF4-FFF2-40B4-BE49-F238E27FC236}">
+                <a16:creationId xmlns:a16="http://schemas.microsoft.com/office/drawing/2014/main" id="{DF938FB7-354C-70CD-E746-4F325631C033}"/>
+              </a:ext>
+            </a:extLst>
+          </p:cNvPr>
+          <p:cNvCxnSpPr/>
+          <p:nvPr/>
+        </p:nvCxnSpPr>
+        <p:spPr>
+          <a:xfrm flipV="1">
+            <a:off x="357051" y="1997881"/>
+            <a:ext cx="452846" cy="288119"/>
+          </a:xfrm>
+          <a:prstGeom prst="straightConnector1">
+            <a:avLst/>
+          </a:prstGeom>
+          <a:ln>
+            <a:solidFill>
+              <a:schemeClr val="bg1"/>
+            </a:solidFill>
+            <a:tailEnd type="triangle"/>
+          </a:ln>
+        </p:spPr>
+        <p:style>
+          <a:lnRef idx="1">
+            <a:schemeClr val="accent1"/>
+          </a:lnRef>
+          <a:fillRef idx="0">
+            <a:schemeClr val="accent1"/>
+          </a:fillRef>
+          <a:effectRef idx="0">
+            <a:schemeClr val="accent1"/>
+          </a:effectRef>
+          <a:fontRef idx="minor">
+            <a:schemeClr val="tx1"/>
+          </a:fontRef>
+        </p:style>
+      </p:cxnSp>
+      <p:sp>
+        <p:nvSpPr>
+          <p:cNvPr id="4" name="TextBox 3">
+            <a:extLst>
+              <a:ext uri="{FF2B5EF4-FFF2-40B4-BE49-F238E27FC236}">
+                <a16:creationId xmlns:a16="http://schemas.microsoft.com/office/drawing/2014/main" id="{9B80FB4E-CA0D-72A4-1BC1-AECF6105BC26}"/>
+              </a:ext>
+            </a:extLst>
+          </p:cNvPr>
+          <p:cNvSpPr txBox="1"/>
+          <p:nvPr/>
+        </p:nvSpPr>
+        <p:spPr>
+          <a:xfrm>
+            <a:off x="55365" y="2136191"/>
+            <a:ext cx="301686" cy="369332"/>
+          </a:xfrm>
+          <a:prstGeom prst="rect">
+            <a:avLst/>
+          </a:prstGeom>
+          <a:noFill/>
+        </p:spPr>
+        <p:txBody>
+          <a:bodyPr wrap="none" rtlCol="0">
+            <a:spAutoFit/>
+          </a:bodyPr>
+          <a:lstStyle/>
+          <a:p>
+            <a:r>
+              <a:rPr lang="en-US" dirty="0">
+                <a:solidFill>
+                  <a:schemeClr val="bg1"/>
+                </a:solidFill>
+              </a:rPr>
+              <a:t>1</a:t>
+            </a:r>
+          </a:p>
+        </p:txBody>
+      </p:sp>
+      <p:cxnSp>
+        <p:nvCxnSpPr>
+          <p:cNvPr id="5" name="Straight Arrow Connector 4">
+            <a:extLst>
+              <a:ext uri="{FF2B5EF4-FFF2-40B4-BE49-F238E27FC236}">
+                <a16:creationId xmlns:a16="http://schemas.microsoft.com/office/drawing/2014/main" id="{865462AD-4975-CE69-BB64-EADA1B67001D}"/>
+              </a:ext>
+            </a:extLst>
+          </p:cNvPr>
+          <p:cNvCxnSpPr>
+            <a:cxnSpLocks/>
+          </p:cNvCxnSpPr>
+          <p:nvPr/>
+        </p:nvCxnSpPr>
+        <p:spPr>
+          <a:xfrm>
+            <a:off x="357051" y="3979750"/>
+            <a:ext cx="452846" cy="329891"/>
+          </a:xfrm>
+          <a:prstGeom prst="straightConnector1">
+            <a:avLst/>
+          </a:prstGeom>
+          <a:ln>
+            <a:solidFill>
+              <a:schemeClr val="bg1"/>
+            </a:solidFill>
+            <a:tailEnd type="triangle"/>
+          </a:ln>
+        </p:spPr>
+        <p:style>
+          <a:lnRef idx="1">
+            <a:schemeClr val="accent1"/>
+          </a:lnRef>
+          <a:fillRef idx="0">
+            <a:schemeClr val="accent1"/>
+          </a:fillRef>
+          <a:effectRef idx="0">
+            <a:schemeClr val="accent1"/>
+          </a:effectRef>
+          <a:fontRef idx="minor">
+            <a:schemeClr val="tx1"/>
+          </a:fontRef>
+        </p:style>
+      </p:cxnSp>
+      <p:cxnSp>
+        <p:nvCxnSpPr>
+          <p:cNvPr id="7" name="Straight Arrow Connector 6">
+            <a:extLst>
+              <a:ext uri="{FF2B5EF4-FFF2-40B4-BE49-F238E27FC236}">
+                <a16:creationId xmlns:a16="http://schemas.microsoft.com/office/drawing/2014/main" id="{4EB5FAC4-561A-6C57-8939-7B231CF5CE4B}"/>
+              </a:ext>
+            </a:extLst>
+          </p:cNvPr>
+          <p:cNvCxnSpPr/>
+          <p:nvPr/>
+        </p:nvCxnSpPr>
+        <p:spPr>
+          <a:xfrm flipV="1">
+            <a:off x="357051" y="3591482"/>
+            <a:ext cx="452846" cy="288119"/>
+          </a:xfrm>
+          <a:prstGeom prst="straightConnector1">
+            <a:avLst/>
+          </a:prstGeom>
+          <a:ln>
+            <a:solidFill>
+              <a:schemeClr val="bg1"/>
+            </a:solidFill>
+            <a:tailEnd type="triangle"/>
+          </a:ln>
+        </p:spPr>
+        <p:style>
+          <a:lnRef idx="1">
+            <a:schemeClr val="accent1"/>
+          </a:lnRef>
+          <a:fillRef idx="0">
+            <a:schemeClr val="accent1"/>
+          </a:fillRef>
+          <a:effectRef idx="0">
+            <a:schemeClr val="accent1"/>
+          </a:effectRef>
+          <a:fontRef idx="minor">
+            <a:schemeClr val="tx1"/>
+          </a:fontRef>
+        </p:style>
+      </p:cxnSp>
+      <p:sp>
+        <p:nvSpPr>
+          <p:cNvPr id="8" name="TextBox 7">
+            <a:extLst>
+              <a:ext uri="{FF2B5EF4-FFF2-40B4-BE49-F238E27FC236}">
+                <a16:creationId xmlns:a16="http://schemas.microsoft.com/office/drawing/2014/main" id="{032846A3-EC31-5EC3-9167-852D1C94737B}"/>
+              </a:ext>
+            </a:extLst>
+          </p:cNvPr>
+          <p:cNvSpPr txBox="1"/>
+          <p:nvPr/>
+        </p:nvSpPr>
+        <p:spPr>
+          <a:xfrm>
+            <a:off x="55365" y="3729792"/>
+            <a:ext cx="301686" cy="369332"/>
+          </a:xfrm>
+          <a:prstGeom prst="rect">
+            <a:avLst/>
+          </a:prstGeom>
+          <a:noFill/>
+        </p:spPr>
+        <p:txBody>
+          <a:bodyPr wrap="none" rtlCol="0">
+            <a:spAutoFit/>
+          </a:bodyPr>
+          <a:lstStyle/>
+          <a:p>
+            <a:r>
+              <a:rPr lang="en-US" dirty="0">
+                <a:solidFill>
+                  <a:schemeClr val="bg1"/>
+                </a:solidFill>
+              </a:rPr>
+              <a:t>2</a:t>
+            </a:r>
+          </a:p>
+        </p:txBody>
+      </p:sp>
+      <p:cxnSp>
+        <p:nvCxnSpPr>
+          <p:cNvPr id="9" name="Straight Arrow Connector 8">
+            <a:extLst>
+              <a:ext uri="{FF2B5EF4-FFF2-40B4-BE49-F238E27FC236}">
+                <a16:creationId xmlns:a16="http://schemas.microsoft.com/office/drawing/2014/main" id="{AD6FD82F-C196-0F9C-CFFB-9393233B60D1}"/>
+              </a:ext>
+            </a:extLst>
+          </p:cNvPr>
+          <p:cNvCxnSpPr>
+            <a:cxnSpLocks/>
+          </p:cNvCxnSpPr>
+          <p:nvPr/>
+        </p:nvCxnSpPr>
+        <p:spPr>
+          <a:xfrm>
+            <a:off x="357051" y="5660959"/>
+            <a:ext cx="452846" cy="329891"/>
+          </a:xfrm>
+          <a:prstGeom prst="straightConnector1">
+            <a:avLst/>
+          </a:prstGeom>
+          <a:ln>
+            <a:solidFill>
+              <a:schemeClr val="bg1"/>
+            </a:solidFill>
+            <a:tailEnd type="triangle"/>
+          </a:ln>
+        </p:spPr>
+        <p:style>
+          <a:lnRef idx="1">
+            <a:schemeClr val="accent1"/>
+          </a:lnRef>
+          <a:fillRef idx="0">
+            <a:schemeClr val="accent1"/>
+          </a:fillRef>
+          <a:effectRef idx="0">
+            <a:schemeClr val="accent1"/>
+          </a:effectRef>
+          <a:fontRef idx="minor">
+            <a:schemeClr val="tx1"/>
+          </a:fontRef>
+        </p:style>
+      </p:cxnSp>
+      <p:cxnSp>
+        <p:nvCxnSpPr>
+          <p:cNvPr id="10" name="Straight Arrow Connector 9">
+            <a:extLst>
+              <a:ext uri="{FF2B5EF4-FFF2-40B4-BE49-F238E27FC236}">
+                <a16:creationId xmlns:a16="http://schemas.microsoft.com/office/drawing/2014/main" id="{A1AA7AAE-292E-BA01-5C72-67A4C1392B02}"/>
+              </a:ext>
+            </a:extLst>
+          </p:cNvPr>
+          <p:cNvCxnSpPr/>
+          <p:nvPr/>
+        </p:nvCxnSpPr>
+        <p:spPr>
+          <a:xfrm flipV="1">
+            <a:off x="357051" y="5272691"/>
+            <a:ext cx="452846" cy="288119"/>
+          </a:xfrm>
+          <a:prstGeom prst="straightConnector1">
+            <a:avLst/>
+          </a:prstGeom>
+          <a:ln>
+            <a:solidFill>
+              <a:schemeClr val="bg1"/>
+            </a:solidFill>
+            <a:tailEnd type="triangle"/>
+          </a:ln>
+        </p:spPr>
+        <p:style>
+          <a:lnRef idx="1">
+            <a:schemeClr val="accent1"/>
+          </a:lnRef>
+          <a:fillRef idx="0">
+            <a:schemeClr val="accent1"/>
+          </a:fillRef>
+          <a:effectRef idx="0">
+            <a:schemeClr val="accent1"/>
+          </a:effectRef>
+          <a:fontRef idx="minor">
+            <a:schemeClr val="tx1"/>
+          </a:fontRef>
+        </p:style>
+      </p:cxnSp>
+      <p:sp>
+        <p:nvSpPr>
+          <p:cNvPr id="11" name="TextBox 10">
+            <a:extLst>
+              <a:ext uri="{FF2B5EF4-FFF2-40B4-BE49-F238E27FC236}">
+                <a16:creationId xmlns:a16="http://schemas.microsoft.com/office/drawing/2014/main" id="{9C922703-AEF1-64E2-0D49-362DA309851E}"/>
+              </a:ext>
+            </a:extLst>
+          </p:cNvPr>
+          <p:cNvSpPr txBox="1"/>
+          <p:nvPr/>
+        </p:nvSpPr>
+        <p:spPr>
+          <a:xfrm>
+            <a:off x="55365" y="5411001"/>
+            <a:ext cx="301686" cy="369332"/>
+          </a:xfrm>
+          <a:prstGeom prst="rect">
+            <a:avLst/>
+          </a:prstGeom>
+          <a:noFill/>
+        </p:spPr>
+        <p:txBody>
+          <a:bodyPr wrap="none" rtlCol="0">
+            <a:spAutoFit/>
+          </a:bodyPr>
+          <a:lstStyle/>
+          <a:p>
+            <a:r>
+              <a:rPr lang="en-US" dirty="0">
+                <a:solidFill>
+                  <a:schemeClr val="bg1"/>
+                </a:solidFill>
+              </a:rPr>
+              <a:t>3</a:t>
             </a:r>
           </a:p>
         </p:txBody>
@@ -3046,8 +3421,8 @@
         </p:nvSpPr>
         <p:spPr>
           <a:xfrm>
-            <a:off x="964194" y="5825905"/>
-            <a:ext cx="4617267" cy="570368"/>
+            <a:off x="964194" y="5638800"/>
+            <a:ext cx="4617267" cy="619125"/>
           </a:xfrm>
           <a:prstGeom prst="rect">
             <a:avLst/>
@@ -3642,6 +4017,381 @@
 Drawing
 M3 writes. M5 releases and travels.
 GP2 is not used for each lift.</a:t>
+            </a:r>
+          </a:p>
+        </p:txBody>
+      </p:sp>
+      <p:cxnSp>
+        <p:nvCxnSpPr>
+          <p:cNvPr id="2" name="Straight Arrow Connector 1">
+            <a:extLst>
+              <a:ext uri="{FF2B5EF4-FFF2-40B4-BE49-F238E27FC236}">
+                <a16:creationId xmlns:a16="http://schemas.microsoft.com/office/drawing/2014/main" id="{6542D194-D697-32F0-4E1E-4240C50E0124}"/>
+              </a:ext>
+            </a:extLst>
+          </p:cNvPr>
+          <p:cNvCxnSpPr>
+            <a:cxnSpLocks/>
+          </p:cNvCxnSpPr>
+          <p:nvPr/>
+        </p:nvCxnSpPr>
+        <p:spPr>
+          <a:xfrm>
+            <a:off x="357051" y="2386149"/>
+            <a:ext cx="452846" cy="329891"/>
+          </a:xfrm>
+          <a:prstGeom prst="straightConnector1">
+            <a:avLst/>
+          </a:prstGeom>
+          <a:ln>
+            <a:solidFill>
+              <a:schemeClr val="bg1"/>
+            </a:solidFill>
+            <a:tailEnd type="triangle"/>
+          </a:ln>
+        </p:spPr>
+        <p:style>
+          <a:lnRef idx="1">
+            <a:schemeClr val="accent1"/>
+          </a:lnRef>
+          <a:fillRef idx="0">
+            <a:schemeClr val="accent1"/>
+          </a:fillRef>
+          <a:effectRef idx="0">
+            <a:schemeClr val="accent1"/>
+          </a:effectRef>
+          <a:fontRef idx="minor">
+            <a:schemeClr val="tx1"/>
+          </a:fontRef>
+        </p:style>
+      </p:cxnSp>
+      <p:cxnSp>
+        <p:nvCxnSpPr>
+          <p:cNvPr id="3" name="Straight Arrow Connector 2">
+            <a:extLst>
+              <a:ext uri="{FF2B5EF4-FFF2-40B4-BE49-F238E27FC236}">
+                <a16:creationId xmlns:a16="http://schemas.microsoft.com/office/drawing/2014/main" id="{8C567A2A-2704-8E07-2D95-4327FCD2806C}"/>
+              </a:ext>
+            </a:extLst>
+          </p:cNvPr>
+          <p:cNvCxnSpPr/>
+          <p:nvPr/>
+        </p:nvCxnSpPr>
+        <p:spPr>
+          <a:xfrm flipV="1">
+            <a:off x="357051" y="1997881"/>
+            <a:ext cx="452846" cy="288119"/>
+          </a:xfrm>
+          <a:prstGeom prst="straightConnector1">
+            <a:avLst/>
+          </a:prstGeom>
+          <a:ln>
+            <a:solidFill>
+              <a:schemeClr val="bg1"/>
+            </a:solidFill>
+            <a:tailEnd type="triangle"/>
+          </a:ln>
+        </p:spPr>
+        <p:style>
+          <a:lnRef idx="1">
+            <a:schemeClr val="accent1"/>
+          </a:lnRef>
+          <a:fillRef idx="0">
+            <a:schemeClr val="accent1"/>
+          </a:fillRef>
+          <a:effectRef idx="0">
+            <a:schemeClr val="accent1"/>
+          </a:effectRef>
+          <a:fontRef idx="minor">
+            <a:schemeClr val="tx1"/>
+          </a:fontRef>
+        </p:style>
+      </p:cxnSp>
+      <p:sp>
+        <p:nvSpPr>
+          <p:cNvPr id="4" name="TextBox 3">
+            <a:extLst>
+              <a:ext uri="{FF2B5EF4-FFF2-40B4-BE49-F238E27FC236}">
+                <a16:creationId xmlns:a16="http://schemas.microsoft.com/office/drawing/2014/main" id="{D5EA784C-D6BF-D4E3-CADC-3DD48C5905C7}"/>
+              </a:ext>
+            </a:extLst>
+          </p:cNvPr>
+          <p:cNvSpPr txBox="1"/>
+          <p:nvPr/>
+        </p:nvSpPr>
+        <p:spPr>
+          <a:xfrm>
+            <a:off x="55365" y="2136191"/>
+            <a:ext cx="301686" cy="369332"/>
+          </a:xfrm>
+          <a:prstGeom prst="rect">
+            <a:avLst/>
+          </a:prstGeom>
+          <a:noFill/>
+        </p:spPr>
+        <p:txBody>
+          <a:bodyPr wrap="none" rtlCol="0">
+            <a:spAutoFit/>
+          </a:bodyPr>
+          <a:lstStyle/>
+          <a:p>
+            <a:r>
+              <a:rPr lang="en-US" dirty="0">
+                <a:solidFill>
+                  <a:schemeClr val="bg1"/>
+                </a:solidFill>
+              </a:rPr>
+              <a:t>1</a:t>
+            </a:r>
+          </a:p>
+        </p:txBody>
+      </p:sp>
+      <p:cxnSp>
+        <p:nvCxnSpPr>
+          <p:cNvPr id="5" name="Straight Arrow Connector 4">
+            <a:extLst>
+              <a:ext uri="{FF2B5EF4-FFF2-40B4-BE49-F238E27FC236}">
+                <a16:creationId xmlns:a16="http://schemas.microsoft.com/office/drawing/2014/main" id="{19DBAFF7-FFB6-63D6-7FD2-BBBA76E11D1F}"/>
+              </a:ext>
+            </a:extLst>
+          </p:cNvPr>
+          <p:cNvCxnSpPr>
+            <a:cxnSpLocks/>
+          </p:cNvCxnSpPr>
+          <p:nvPr/>
+        </p:nvCxnSpPr>
+        <p:spPr>
+          <a:xfrm>
+            <a:off x="357051" y="3979750"/>
+            <a:ext cx="452846" cy="329891"/>
+          </a:xfrm>
+          <a:prstGeom prst="straightConnector1">
+            <a:avLst/>
+          </a:prstGeom>
+          <a:ln>
+            <a:solidFill>
+              <a:schemeClr val="bg1"/>
+            </a:solidFill>
+            <a:tailEnd type="triangle"/>
+          </a:ln>
+        </p:spPr>
+        <p:style>
+          <a:lnRef idx="1">
+            <a:schemeClr val="accent1"/>
+          </a:lnRef>
+          <a:fillRef idx="0">
+            <a:schemeClr val="accent1"/>
+          </a:fillRef>
+          <a:effectRef idx="0">
+            <a:schemeClr val="accent1"/>
+          </a:effectRef>
+          <a:fontRef idx="minor">
+            <a:schemeClr val="tx1"/>
+          </a:fontRef>
+        </p:style>
+      </p:cxnSp>
+      <p:cxnSp>
+        <p:nvCxnSpPr>
+          <p:cNvPr id="7" name="Straight Arrow Connector 6">
+            <a:extLst>
+              <a:ext uri="{FF2B5EF4-FFF2-40B4-BE49-F238E27FC236}">
+                <a16:creationId xmlns:a16="http://schemas.microsoft.com/office/drawing/2014/main" id="{BA00A045-C351-DD3D-D101-6A5AC92467DB}"/>
+              </a:ext>
+            </a:extLst>
+          </p:cNvPr>
+          <p:cNvCxnSpPr/>
+          <p:nvPr/>
+        </p:nvCxnSpPr>
+        <p:spPr>
+          <a:xfrm flipV="1">
+            <a:off x="357051" y="3591482"/>
+            <a:ext cx="452846" cy="288119"/>
+          </a:xfrm>
+          <a:prstGeom prst="straightConnector1">
+            <a:avLst/>
+          </a:prstGeom>
+          <a:ln>
+            <a:solidFill>
+              <a:schemeClr val="bg1"/>
+            </a:solidFill>
+            <a:tailEnd type="triangle"/>
+          </a:ln>
+        </p:spPr>
+        <p:style>
+          <a:lnRef idx="1">
+            <a:schemeClr val="accent1"/>
+          </a:lnRef>
+          <a:fillRef idx="0">
+            <a:schemeClr val="accent1"/>
+          </a:fillRef>
+          <a:effectRef idx="0">
+            <a:schemeClr val="accent1"/>
+          </a:effectRef>
+          <a:fontRef idx="minor">
+            <a:schemeClr val="tx1"/>
+          </a:fontRef>
+        </p:style>
+      </p:cxnSp>
+      <p:sp>
+        <p:nvSpPr>
+          <p:cNvPr id="8" name="TextBox 7">
+            <a:extLst>
+              <a:ext uri="{FF2B5EF4-FFF2-40B4-BE49-F238E27FC236}">
+                <a16:creationId xmlns:a16="http://schemas.microsoft.com/office/drawing/2014/main" id="{A512D059-DF69-25C1-FE83-C2B1E613366E}"/>
+              </a:ext>
+            </a:extLst>
+          </p:cNvPr>
+          <p:cNvSpPr txBox="1"/>
+          <p:nvPr/>
+        </p:nvSpPr>
+        <p:spPr>
+          <a:xfrm>
+            <a:off x="55365" y="3729792"/>
+            <a:ext cx="301686" cy="369332"/>
+          </a:xfrm>
+          <a:prstGeom prst="rect">
+            <a:avLst/>
+          </a:prstGeom>
+          <a:noFill/>
+        </p:spPr>
+        <p:txBody>
+          <a:bodyPr wrap="none" rtlCol="0">
+            <a:spAutoFit/>
+          </a:bodyPr>
+          <a:lstStyle/>
+          <a:p>
+            <a:r>
+              <a:rPr lang="en-US" dirty="0">
+                <a:solidFill>
+                  <a:schemeClr val="bg1"/>
+                </a:solidFill>
+              </a:rPr>
+              <a:t>2</a:t>
+            </a:r>
+          </a:p>
+        </p:txBody>
+      </p:sp>
+      <p:cxnSp>
+        <p:nvCxnSpPr>
+          <p:cNvPr id="9" name="Straight Arrow Connector 8">
+            <a:extLst>
+              <a:ext uri="{FF2B5EF4-FFF2-40B4-BE49-F238E27FC236}">
+                <a16:creationId xmlns:a16="http://schemas.microsoft.com/office/drawing/2014/main" id="{DBCF5475-69C6-437F-23A1-2BD6FA4AFFDC}"/>
+              </a:ext>
+            </a:extLst>
+          </p:cNvPr>
+          <p:cNvCxnSpPr>
+            <a:cxnSpLocks/>
+          </p:cNvCxnSpPr>
+          <p:nvPr/>
+        </p:nvCxnSpPr>
+        <p:spPr>
+          <a:xfrm>
+            <a:off x="357051" y="5660959"/>
+            <a:ext cx="452846" cy="329891"/>
+          </a:xfrm>
+          <a:prstGeom prst="straightConnector1">
+            <a:avLst/>
+          </a:prstGeom>
+          <a:ln>
+            <a:solidFill>
+              <a:schemeClr val="bg1"/>
+            </a:solidFill>
+            <a:tailEnd type="triangle"/>
+          </a:ln>
+        </p:spPr>
+        <p:style>
+          <a:lnRef idx="1">
+            <a:schemeClr val="accent1"/>
+          </a:lnRef>
+          <a:fillRef idx="0">
+            <a:schemeClr val="accent1"/>
+          </a:fillRef>
+          <a:effectRef idx="0">
+            <a:schemeClr val="accent1"/>
+          </a:effectRef>
+          <a:fontRef idx="minor">
+            <a:schemeClr val="tx1"/>
+          </a:fontRef>
+        </p:style>
+      </p:cxnSp>
+      <p:cxnSp>
+        <p:nvCxnSpPr>
+          <p:cNvPr id="10" name="Straight Arrow Connector 9">
+            <a:extLst>
+              <a:ext uri="{FF2B5EF4-FFF2-40B4-BE49-F238E27FC236}">
+                <a16:creationId xmlns:a16="http://schemas.microsoft.com/office/drawing/2014/main" id="{2FE14961-6BCB-4DED-5CCF-6FF32D2FFBEC}"/>
+              </a:ext>
+            </a:extLst>
+          </p:cNvPr>
+          <p:cNvCxnSpPr/>
+          <p:nvPr/>
+        </p:nvCxnSpPr>
+        <p:spPr>
+          <a:xfrm flipV="1">
+            <a:off x="357051" y="5272691"/>
+            <a:ext cx="452846" cy="288119"/>
+          </a:xfrm>
+          <a:prstGeom prst="straightConnector1">
+            <a:avLst/>
+          </a:prstGeom>
+          <a:ln>
+            <a:solidFill>
+              <a:schemeClr val="bg1"/>
+            </a:solidFill>
+            <a:tailEnd type="triangle"/>
+          </a:ln>
+        </p:spPr>
+        <p:style>
+          <a:lnRef idx="1">
+            <a:schemeClr val="accent1"/>
+          </a:lnRef>
+          <a:fillRef idx="0">
+            <a:schemeClr val="accent1"/>
+          </a:fillRef>
+          <a:effectRef idx="0">
+            <a:schemeClr val="accent1"/>
+          </a:effectRef>
+          <a:fontRef idx="minor">
+            <a:schemeClr val="tx1"/>
+          </a:fontRef>
+        </p:style>
+      </p:cxnSp>
+      <p:sp>
+        <p:nvSpPr>
+          <p:cNvPr id="11" name="TextBox 10">
+            <a:extLst>
+              <a:ext uri="{FF2B5EF4-FFF2-40B4-BE49-F238E27FC236}">
+                <a16:creationId xmlns:a16="http://schemas.microsoft.com/office/drawing/2014/main" id="{D15D1ABF-324F-4502-ADF2-430C744F7EBE}"/>
+              </a:ext>
+            </a:extLst>
+          </p:cNvPr>
+          <p:cNvSpPr txBox="1"/>
+          <p:nvPr/>
+        </p:nvSpPr>
+        <p:spPr>
+          <a:xfrm>
+            <a:off x="55365" y="5411001"/>
+            <a:ext cx="301686" cy="369332"/>
+          </a:xfrm>
+          <a:prstGeom prst="rect">
+            <a:avLst/>
+          </a:prstGeom>
+          <a:noFill/>
+        </p:spPr>
+        <p:txBody>
+          <a:bodyPr wrap="none" rtlCol="0">
+            <a:spAutoFit/>
+          </a:bodyPr>
+          <a:lstStyle/>
+          <a:p>
+            <a:r>
+              <a:rPr lang="en-US" dirty="0">
+                <a:solidFill>
+                  <a:schemeClr val="bg1"/>
+                </a:solidFill>
+              </a:rPr>
+              <a:t>3</a:t>
             </a:r>
           </a:p>
         </p:txBody>
@@ -5050,7 +5800,7 @@
               </a:defRPr>
             </a:pPr>
             <a:r>
-              <a:rPr sz="1200" b="0">
+              <a:rPr sz="1200" b="0" dirty="0">
                 <a:solidFill>
                   <a:srgbClr val="59616B"/>
                 </a:solidFill>
@@ -5058,7 +5808,29 @@
                 <a:ea typeface="Helvetica Neue"/>
                 <a:cs typeface="Helvetica Neue"/>
               </a:rPr>
-              <a:t>Convert HX711 readings into reliable force units.</a:t>
+              <a:t>Convert HX711 readings into </a:t>
+            </a:r>
+            <a:r>
+              <a:rPr lang="en-US" sz="1200" b="0" dirty="0">
+                <a:solidFill>
+                  <a:srgbClr val="59616B"/>
+                </a:solidFill>
+                <a:latin typeface="Helvetica Neue"/>
+                <a:ea typeface="Helvetica Neue"/>
+                <a:cs typeface="Helvetica Neue"/>
+              </a:rPr>
+              <a:t>reproducible</a:t>
+            </a:r>
+            <a:r>
+              <a:rPr sz="1200" b="0" dirty="0">
+                <a:solidFill>
+                  <a:srgbClr val="59616B"/>
+                </a:solidFill>
+                <a:latin typeface="Helvetica Neue"/>
+                <a:ea typeface="Helvetica Neue"/>
+                <a:cs typeface="Helvetica Neue"/>
+              </a:rPr>
+              <a:t> force units.</a:t>
             </a:r>
           </a:p>
         </p:txBody>
@@ -5306,7 +6078,7 @@
               </a:defRPr>
             </a:pPr>
             <a:r>
-              <a:rPr sz="1200" b="0">
+              <a:rPr sz="1200" b="0" dirty="0">
                 <a:solidFill>
                   <a:srgbClr val="59616B"/>
                 </a:solidFill>
@@ -5581,7 +6353,7 @@
                 <a:ea typeface="Helvetica Neue"/>
                 <a:cs typeface="Helvetica Neue"/>
               </a:rPr>
-              <a:t>works with pens or pencils.</a:t>
+              <a:t>pens or pencils.</a:t>
             </a:r>
             <a:endParaRPr sz="1200" b="0" dirty="0">
               <a:solidFill>
@@ -10385,13 +11157,13 @@
           <a:lstStyle/>
           <a:p>
             <a:r>
-              <a:rPr lang="en-US" sz="3100" b="1">
+              <a:rPr lang="en-US" sz="3100" b="1" dirty="0">
                 <a:solidFill>
                   <a:srgbClr val="14191E"/>
                 </a:solidFill>
                 <a:latin typeface="Aptos" panose="020B0004020202020204" pitchFamily="34" charset="0"/>
               </a:rPr>
-              <a:t>Opto-isolation keeps the controller interface safe</a:t>
+              <a:t>Opto-isolation</a:t>
             </a:r>
           </a:p>
         </p:txBody>
@@ -10410,7 +11182,7 @@
         </p:nvSpPr>
         <p:spPr>
           <a:xfrm>
-            <a:off x="400050" y="1430094"/>
+            <a:off x="400050" y="1094044"/>
             <a:ext cx="11391900" cy="261610"/>
           </a:xfrm>
           <a:prstGeom prst="rect">
@@ -10425,13 +11197,13 @@
           <a:lstStyle/>
           <a:p>
             <a:r>
-              <a:rPr lang="en-US" sz="1700">
+              <a:rPr lang="en-US" sz="1700" dirty="0">
                 <a:solidFill>
                   <a:srgbClr val="5B6571"/>
                 </a:solidFill>
                 <a:latin typeface="Aptos" panose="020B0004020202020204" pitchFamily="34" charset="0"/>
               </a:rPr>
-              <a:t>Three isolated digital paths carry commands and status without sharing grounds.</a:t>
+              <a:t>Digital paths carry commands and status without sharing grounds.</a:t>
             </a:r>
           </a:p>
         </p:txBody>
@@ -10450,7 +11222,7 @@
         </p:nvSpPr>
         <p:spPr>
           <a:xfrm>
-            <a:off x="660400" y="1925394"/>
+            <a:off x="663575" y="2280364"/>
             <a:ext cx="3302000" cy="261610"/>
           </a:xfrm>
           <a:prstGeom prst="rect">
@@ -10491,7 +11263,7 @@
         </p:nvSpPr>
         <p:spPr>
           <a:xfrm>
-            <a:off x="4445000" y="1925394"/>
+            <a:off x="4448175" y="2280364"/>
             <a:ext cx="3302000" cy="261610"/>
           </a:xfrm>
           <a:prstGeom prst="rect">
@@ -10507,13 +11279,13 @@
           <a:p>
             <a:pPr algn="ctr"/>
             <a:r>
-              <a:rPr lang="en-US" sz="1700" b="1">
+              <a:rPr lang="en-US" sz="1700" b="1" dirty="0">
                 <a:solidFill>
                   <a:srgbClr val="14191E"/>
                 </a:solidFill>
                 <a:latin typeface="Aptos" panose="020B0004020202020204" pitchFamily="34" charset="0"/>
               </a:rPr>
-              <a:t>PC817C isolation</a:t>
+              <a:t>Opto-isolation</a:t>
             </a:r>
           </a:p>
         </p:txBody>
@@ -10532,7 +11304,7 @@
         </p:nvSpPr>
         <p:spPr>
           <a:xfrm>
-            <a:off x="8229600" y="1925394"/>
+            <a:off x="8232775" y="2280364"/>
             <a:ext cx="3302000" cy="261610"/>
           </a:xfrm>
           <a:prstGeom prst="rect">
@@ -10573,7 +11345,7 @@
         </p:nvSpPr>
         <p:spPr>
           <a:xfrm>
-            <a:off x="660400" y="2235572"/>
+            <a:off x="663575" y="2590542"/>
             <a:ext cx="3302000" cy="200055"/>
           </a:xfrm>
           <a:prstGeom prst="rect">
@@ -10614,7 +11386,7 @@
         </p:nvSpPr>
         <p:spPr>
           <a:xfrm>
-            <a:off x="8229600" y="2235572"/>
+            <a:off x="8232775" y="2590542"/>
             <a:ext cx="3302000" cy="200055"/>
           </a:xfrm>
           <a:prstGeom prst="rect">
@@ -10655,7 +11427,7 @@
         </p:nvCxnSpPr>
         <p:spPr>
           <a:xfrm>
-            <a:off x="3962400" y="2946400"/>
+            <a:off x="3965575" y="3301370"/>
             <a:ext cx="762000" cy="0"/>
           </a:xfrm>
           <a:prstGeom prst="line">
@@ -10697,7 +11469,7 @@
         </p:nvCxnSpPr>
         <p:spPr>
           <a:xfrm>
-            <a:off x="7467600" y="2946400"/>
+            <a:off x="7470775" y="3301370"/>
             <a:ext cx="762000" cy="0"/>
           </a:xfrm>
           <a:prstGeom prst="line">
@@ -10739,7 +11511,7 @@
         </p:nvCxnSpPr>
         <p:spPr>
           <a:xfrm>
-            <a:off x="3962400" y="3771900"/>
+            <a:off x="3965575" y="4126870"/>
             <a:ext cx="762000" cy="0"/>
           </a:xfrm>
           <a:prstGeom prst="line">
@@ -10781,7 +11553,7 @@
         </p:nvCxnSpPr>
         <p:spPr>
           <a:xfrm>
-            <a:off x="7467600" y="3771900"/>
+            <a:off x="7470775" y="4126870"/>
             <a:ext cx="762000" cy="0"/>
           </a:xfrm>
           <a:prstGeom prst="line">
@@ -10823,7 +11595,7 @@
         </p:nvCxnSpPr>
         <p:spPr>
           <a:xfrm flipH="1">
-            <a:off x="3962400" y="4597400"/>
+            <a:off x="3965575" y="4952370"/>
             <a:ext cx="762000" cy="0"/>
           </a:xfrm>
           <a:prstGeom prst="line">
@@ -10865,7 +11637,7 @@
         </p:nvCxnSpPr>
         <p:spPr>
           <a:xfrm flipH="1">
-            <a:off x="7467600" y="4597400"/>
+            <a:off x="7470775" y="4952370"/>
             <a:ext cx="762000" cy="0"/>
           </a:xfrm>
           <a:prstGeom prst="line">
@@ -10907,7 +11679,7 @@
         </p:nvSpPr>
         <p:spPr>
           <a:xfrm>
-            <a:off x="660400" y="2667000"/>
+            <a:off x="663575" y="3021970"/>
             <a:ext cx="3302000" cy="558800"/>
           </a:xfrm>
           <a:prstGeom prst="roundRect">
@@ -10944,13 +11716,13 @@
           <a:p>
             <a:pPr algn="ctr"/>
             <a:r>
-              <a:rPr lang="en-US" sz="1600">
+              <a:rPr lang="en-US" sz="1600" dirty="0">
                 <a:solidFill>
                   <a:srgbClr val="14191E"/>
                 </a:solidFill>
                 <a:latin typeface="Aptos" panose="020B0004020202020204" pitchFamily="34" charset="0"/>
               </a:rPr>
-              <a:t>ENA - M3 / M5</a:t>
+              <a:t>ENA - M3 / M5 (forward/retract)</a:t>
             </a:r>
           </a:p>
         </p:txBody>
@@ -10969,7 +11741,7 @@
         </p:nvSpPr>
         <p:spPr>
           <a:xfrm>
-            <a:off x="4724400" y="2667000"/>
+            <a:off x="4727575" y="3021970"/>
             <a:ext cx="2743200" cy="558800"/>
           </a:xfrm>
           <a:prstGeom prst="roundRect">
@@ -11031,7 +11803,7 @@
         </p:nvSpPr>
         <p:spPr>
           <a:xfrm>
-            <a:off x="8229600" y="2667000"/>
+            <a:off x="8232775" y="3021970"/>
             <a:ext cx="3302000" cy="558800"/>
           </a:xfrm>
           <a:prstGeom prst="roundRect">
@@ -11093,7 +11865,7 @@
         </p:nvSpPr>
         <p:spPr>
           <a:xfrm>
-            <a:off x="660400" y="3492500"/>
+            <a:off x="663575" y="3847470"/>
             <a:ext cx="3302000" cy="558800"/>
           </a:xfrm>
           <a:prstGeom prst="roundRect">
@@ -11130,13 +11902,13 @@
           <a:p>
             <a:pPr algn="ctr"/>
             <a:r>
-              <a:rPr lang="en-US" sz="1600">
+              <a:rPr lang="en-US" sz="1600" dirty="0">
                 <a:solidFill>
                   <a:srgbClr val="14191E"/>
                 </a:solidFill>
                 <a:latin typeface="Aptos" panose="020B0004020202020204" pitchFamily="34" charset="0"/>
               </a:rPr>
-              <a:t>Aux 0 - arm request</a:t>
+              <a:t>Aux 0 - arm request (homing start)</a:t>
             </a:r>
           </a:p>
         </p:txBody>
@@ -11155,7 +11927,7 @@
         </p:nvSpPr>
         <p:spPr>
           <a:xfrm>
-            <a:off x="4724400" y="3492500"/>
+            <a:off x="4727575" y="3847470"/>
             <a:ext cx="2743200" cy="558800"/>
           </a:xfrm>
           <a:prstGeom prst="roundRect">
@@ -11217,7 +11989,7 @@
         </p:nvSpPr>
         <p:spPr>
           <a:xfrm>
-            <a:off x="8229600" y="3492500"/>
+            <a:off x="8232775" y="3847470"/>
             <a:ext cx="3302000" cy="558800"/>
           </a:xfrm>
           <a:prstGeom prst="roundRect">
@@ -11279,7 +12051,7 @@
         </p:nvSpPr>
         <p:spPr>
           <a:xfrm>
-            <a:off x="660400" y="4318000"/>
+            <a:off x="663575" y="4672970"/>
             <a:ext cx="3302000" cy="558800"/>
           </a:xfrm>
           <a:prstGeom prst="roundRect">
@@ -11316,13 +12088,13 @@
           <a:p>
             <a:pPr algn="ctr"/>
             <a:r>
-              <a:rPr lang="en-US" sz="1600">
+              <a:rPr lang="en-US" sz="1600" dirty="0">
                 <a:solidFill>
                   <a:srgbClr val="14191E"/>
                 </a:solidFill>
                 <a:latin typeface="Aptos" panose="020B0004020202020204" pitchFamily="34" charset="0"/>
               </a:rPr>
-              <a:t>LIMA / PRB* - input</a:t>
+              <a:t>PRB – input signal + encoder</a:t>
             </a:r>
           </a:p>
         </p:txBody>
@@ -11341,7 +12113,7 @@
         </p:nvSpPr>
         <p:spPr>
           <a:xfrm>
-            <a:off x="4724400" y="4318000"/>
+            <a:off x="4727575" y="4672970"/>
             <a:ext cx="2743200" cy="558800"/>
           </a:xfrm>
           <a:prstGeom prst="roundRect">
@@ -11403,7 +12175,7 @@
         </p:nvSpPr>
         <p:spPr>
           <a:xfrm>
-            <a:off x="8229600" y="4318000"/>
+            <a:off x="8232775" y="4672970"/>
             <a:ext cx="3302000" cy="558800"/>
           </a:xfrm>
           <a:prstGeom prst="roundRect">
@@ -11447,192 +12219,6 @@
                 <a:latin typeface="Aptos" panose="020B0004020202020204" pitchFamily="34" charset="0"/>
               </a:rPr>
               <a:t>GP27 - status output</a:t>
-            </a:r>
-          </a:p>
-        </p:txBody>
-      </p:sp>
-      <p:sp>
-        <p:nvSpPr>
-          <p:cNvPr id="64" name="Rectangle: Rounded Corners 63">
-            <a:extLst>
-              <a:ext uri="{FF2B5EF4-FFF2-40B4-BE49-F238E27FC236}">
-                <a16:creationId xmlns:a16="http://schemas.microsoft.com/office/drawing/2014/main" id="{7E909289-9870-D8C1-CABE-13381B43C772}"/>
-              </a:ext>
-            </a:extLst>
-          </p:cNvPr>
-          <p:cNvSpPr/>
-          <p:nvPr/>
-        </p:nvSpPr>
-        <p:spPr>
-          <a:xfrm>
-            <a:off x="660400" y="5207000"/>
-            <a:ext cx="10871200" cy="787400"/>
-          </a:xfrm>
-          <a:prstGeom prst="roundRect">
-            <a:avLst/>
-          </a:prstGeom>
-          <a:solidFill>
-            <a:srgbClr val="ECF6FF"/>
-          </a:solidFill>
-          <a:ln w="19050">
-            <a:noFill/>
-            <a:prstDash val="solid"/>
-          </a:ln>
-          <a:effectLst/>
-          <a:extLst>
-            <a:ext uri="{91240B29-F687-4F45-9708-019B960494DF}">
-              <a14:hiddenLine xmlns:a14="http://schemas.microsoft.com/office/drawing/2010/main" w="19050">
-                <a:solidFill>
-                  <a:schemeClr val="accent1">
-                    <a:shade val="15000"/>
-                  </a:schemeClr>
-                </a:solidFill>
-                <a:prstDash val="solid"/>
-              </a14:hiddenLine>
-            </a:ext>
-          </a:extLst>
-        </p:spPr>
-        <p:style>
-          <a:lnRef idx="2">
-            <a:schemeClr val="accent1">
-              <a:shade val="15000"/>
-            </a:schemeClr>
-          </a:lnRef>
-          <a:fillRef idx="1">
-            <a:schemeClr val="accent1"/>
-          </a:fillRef>
-          <a:effectRef idx="0">
-            <a:schemeClr val="accent1"/>
-          </a:effectRef>
-          <a:fontRef idx="minor">
-            <a:schemeClr val="lt1"/>
-          </a:fontRef>
-        </p:style>
-        <p:txBody>
-          <a:bodyPr rtlCol="0" anchor="ctr"/>
-          <a:lstStyle/>
-          <a:p>
-            <a:pPr algn="ctr"/>
-            <a:endParaRPr lang="en-US"/>
-          </a:p>
-        </p:txBody>
-      </p:sp>
-      <p:sp>
-        <p:nvSpPr>
-          <p:cNvPr id="65" name="TextBox 64">
-            <a:extLst>
-              <a:ext uri="{FF2B5EF4-FFF2-40B4-BE49-F238E27FC236}">
-                <a16:creationId xmlns:a16="http://schemas.microsoft.com/office/drawing/2014/main" id="{25DCC5BC-AFA3-ACE6-E61A-0FB0D51FBA8C}"/>
-              </a:ext>
-            </a:extLst>
-          </p:cNvPr>
-          <p:cNvSpPr txBox="1"/>
-          <p:nvPr/>
-        </p:nvSpPr>
-        <p:spPr>
-          <a:xfrm>
-            <a:off x="914400" y="5367094"/>
-            <a:ext cx="10363200" cy="261610"/>
-          </a:xfrm>
-          <a:prstGeom prst="rect">
-            <a:avLst/>
-          </a:prstGeom>
-          <a:noFill/>
-        </p:spPr>
-        <p:txBody>
-          <a:bodyPr vert="horz" wrap="square" lIns="0" tIns="0" rIns="0" bIns="0" rtlCol="0" anchor="ctr">
-            <a:spAutoFit/>
-          </a:bodyPr>
-          <a:lstStyle/>
-          <a:p>
-            <a:r>
-              <a:rPr lang="en-US" sz="1700" b="1">
-                <a:solidFill>
-                  <a:srgbClr val="14191E"/>
-                </a:solidFill>
-                <a:latin typeface="Aptos" panose="020B0004020202020204" pitchFamily="34" charset="0"/>
-              </a:rPr>
-              <a:t>Why this matters</a:t>
-            </a:r>
-          </a:p>
-        </p:txBody>
-      </p:sp>
-      <p:sp>
-        <p:nvSpPr>
-          <p:cNvPr id="66" name="TextBox 65">
-            <a:extLst>
-              <a:ext uri="{FF2B5EF4-FFF2-40B4-BE49-F238E27FC236}">
-                <a16:creationId xmlns:a16="http://schemas.microsoft.com/office/drawing/2014/main" id="{08A7FCB3-6D50-AB76-76AB-0E9CB31F33DB}"/>
-              </a:ext>
-            </a:extLst>
-          </p:cNvPr>
-          <p:cNvSpPr txBox="1"/>
-          <p:nvPr/>
-        </p:nvSpPr>
-        <p:spPr>
-          <a:xfrm>
-            <a:off x="914400" y="5838483"/>
-            <a:ext cx="10363200" cy="230832"/>
-          </a:xfrm>
-          <a:prstGeom prst="rect">
-            <a:avLst/>
-          </a:prstGeom>
-          <a:noFill/>
-        </p:spPr>
-        <p:txBody>
-          <a:bodyPr vert="horz" wrap="square" lIns="0" tIns="0" rIns="0" bIns="0" rtlCol="0" anchor="ctr">
-            <a:spAutoFit/>
-          </a:bodyPr>
-          <a:lstStyle/>
-          <a:p>
-            <a:r>
-              <a:rPr lang="en-US" sz="1500">
-                <a:solidFill>
-                  <a:srgbClr val="5B6571"/>
-                </a:solidFill>
-                <a:latin typeface="Aptos" panose="020B0004020202020204" pitchFamily="34" charset="0"/>
-              </a:rPr>
-              <a:t>Only digital states cross the boundary; power, grounds, load-cell data, motor current, and UART stay in their own domains.</a:t>
-            </a:r>
-          </a:p>
-        </p:txBody>
-      </p:sp>
-      <p:sp>
-        <p:nvSpPr>
-          <p:cNvPr id="67" name="TextBox 66">
-            <a:extLst>
-              <a:ext uri="{FF2B5EF4-FFF2-40B4-BE49-F238E27FC236}">
-                <a16:creationId xmlns:a16="http://schemas.microsoft.com/office/drawing/2014/main" id="{B47A284D-1EC0-BF61-2D16-B771CA52546F}"/>
-              </a:ext>
-            </a:extLst>
-          </p:cNvPr>
-          <p:cNvSpPr txBox="1"/>
-          <p:nvPr/>
-        </p:nvSpPr>
-        <p:spPr>
-          <a:xfrm>
-            <a:off x="660400" y="6142166"/>
-            <a:ext cx="10871200" cy="184666"/>
-          </a:xfrm>
-          <a:prstGeom prst="rect">
-            <a:avLst/>
-          </a:prstGeom>
-          <a:noFill/>
-        </p:spPr>
-        <p:txBody>
-          <a:bodyPr vert="horz" wrap="square" lIns="0" tIns="0" rIns="0" bIns="0" rtlCol="0" anchor="ctr">
-            <a:spAutoFit/>
-          </a:bodyPr>
-          <a:lstStyle/>
-          <a:p>
-            <a:r>
-              <a:rPr lang="en-US" sz="1200">
-                <a:solidFill>
-                  <a:srgbClr val="5B6571"/>
-                </a:solidFill>
-                <a:latin typeface="Aptos" panose="020B0004020202020204" pitchFamily="34" charset="0"/>
-              </a:rPr>
-              <a:t>* GP27 currently returns through LIMA; PRB remains a candidate pending F-08 verification.</a:t>
             </a:r>
           </a:p>
         </p:txBody>
@@ -14028,7 +14614,7 @@
         <p:spPr>
           <a:xfrm>
             <a:off x="964194" y="1616044"/>
-            <a:ext cx="4617267" cy="570368"/>
+            <a:ext cx="4639681" cy="669956"/>
           </a:xfrm>
           <a:prstGeom prst="rect">
             <a:avLst/>
@@ -14624,6 +15210,381 @@
 RP23CNC / grblHAL starts P100 locally.
 Not moved
 HX711 force samples stay inside the Pro Micro toolhead.</a:t>
+            </a:r>
+          </a:p>
+        </p:txBody>
+      </p:sp>
+      <p:cxnSp>
+        <p:nvCxnSpPr>
+          <p:cNvPr id="3" name="Straight Arrow Connector 2">
+            <a:extLst>
+              <a:ext uri="{FF2B5EF4-FFF2-40B4-BE49-F238E27FC236}">
+                <a16:creationId xmlns:a16="http://schemas.microsoft.com/office/drawing/2014/main" id="{416DD1D0-BEA0-D332-CFD5-B00421FA296E}"/>
+              </a:ext>
+            </a:extLst>
+          </p:cNvPr>
+          <p:cNvCxnSpPr>
+            <a:cxnSpLocks/>
+          </p:cNvCxnSpPr>
+          <p:nvPr/>
+        </p:nvCxnSpPr>
+        <p:spPr>
+          <a:xfrm>
+            <a:off x="357051" y="2386149"/>
+            <a:ext cx="452846" cy="329891"/>
+          </a:xfrm>
+          <a:prstGeom prst="straightConnector1">
+            <a:avLst/>
+          </a:prstGeom>
+          <a:ln>
+            <a:solidFill>
+              <a:schemeClr val="bg1"/>
+            </a:solidFill>
+            <a:tailEnd type="triangle"/>
+          </a:ln>
+        </p:spPr>
+        <p:style>
+          <a:lnRef idx="1">
+            <a:schemeClr val="accent1"/>
+          </a:lnRef>
+          <a:fillRef idx="0">
+            <a:schemeClr val="accent1"/>
+          </a:fillRef>
+          <a:effectRef idx="0">
+            <a:schemeClr val="accent1"/>
+          </a:effectRef>
+          <a:fontRef idx="minor">
+            <a:schemeClr val="tx1"/>
+          </a:fontRef>
+        </p:style>
+      </p:cxnSp>
+      <p:cxnSp>
+        <p:nvCxnSpPr>
+          <p:cNvPr id="7" name="Straight Arrow Connector 6">
+            <a:extLst>
+              <a:ext uri="{FF2B5EF4-FFF2-40B4-BE49-F238E27FC236}">
+                <a16:creationId xmlns:a16="http://schemas.microsoft.com/office/drawing/2014/main" id="{6B403B31-6BF3-FCB4-D7AB-1F7764CC148C}"/>
+              </a:ext>
+            </a:extLst>
+          </p:cNvPr>
+          <p:cNvCxnSpPr/>
+          <p:nvPr/>
+        </p:nvCxnSpPr>
+        <p:spPr>
+          <a:xfrm flipV="1">
+            <a:off x="357051" y="1997881"/>
+            <a:ext cx="452846" cy="288119"/>
+          </a:xfrm>
+          <a:prstGeom prst="straightConnector1">
+            <a:avLst/>
+          </a:prstGeom>
+          <a:ln>
+            <a:solidFill>
+              <a:schemeClr val="bg1"/>
+            </a:solidFill>
+            <a:tailEnd type="triangle"/>
+          </a:ln>
+        </p:spPr>
+        <p:style>
+          <a:lnRef idx="1">
+            <a:schemeClr val="accent1"/>
+          </a:lnRef>
+          <a:fillRef idx="0">
+            <a:schemeClr val="accent1"/>
+          </a:fillRef>
+          <a:effectRef idx="0">
+            <a:schemeClr val="accent1"/>
+          </a:effectRef>
+          <a:fontRef idx="minor">
+            <a:schemeClr val="tx1"/>
+          </a:fontRef>
+        </p:style>
+      </p:cxnSp>
+      <p:sp>
+        <p:nvSpPr>
+          <p:cNvPr id="8" name="TextBox 7">
+            <a:extLst>
+              <a:ext uri="{FF2B5EF4-FFF2-40B4-BE49-F238E27FC236}">
+                <a16:creationId xmlns:a16="http://schemas.microsoft.com/office/drawing/2014/main" id="{F0E9E229-D614-79E7-3D4C-14C2FC459731}"/>
+              </a:ext>
+            </a:extLst>
+          </p:cNvPr>
+          <p:cNvSpPr txBox="1"/>
+          <p:nvPr/>
+        </p:nvSpPr>
+        <p:spPr>
+          <a:xfrm>
+            <a:off x="55365" y="2136191"/>
+            <a:ext cx="301686" cy="369332"/>
+          </a:xfrm>
+          <a:prstGeom prst="rect">
+            <a:avLst/>
+          </a:prstGeom>
+          <a:noFill/>
+        </p:spPr>
+        <p:txBody>
+          <a:bodyPr wrap="none" rtlCol="0">
+            <a:spAutoFit/>
+          </a:bodyPr>
+          <a:lstStyle/>
+          <a:p>
+            <a:r>
+              <a:rPr lang="en-US" dirty="0">
+                <a:solidFill>
+                  <a:schemeClr val="bg1"/>
+                </a:solidFill>
+              </a:rPr>
+              <a:t>1</a:t>
+            </a:r>
+          </a:p>
+        </p:txBody>
+      </p:sp>
+      <p:cxnSp>
+        <p:nvCxnSpPr>
+          <p:cNvPr id="9" name="Straight Arrow Connector 8">
+            <a:extLst>
+              <a:ext uri="{FF2B5EF4-FFF2-40B4-BE49-F238E27FC236}">
+                <a16:creationId xmlns:a16="http://schemas.microsoft.com/office/drawing/2014/main" id="{BA65842C-9EF1-966E-E814-3E2060D884F7}"/>
+              </a:ext>
+            </a:extLst>
+          </p:cNvPr>
+          <p:cNvCxnSpPr>
+            <a:cxnSpLocks/>
+          </p:cNvCxnSpPr>
+          <p:nvPr/>
+        </p:nvCxnSpPr>
+        <p:spPr>
+          <a:xfrm>
+            <a:off x="357051" y="3979750"/>
+            <a:ext cx="452846" cy="329891"/>
+          </a:xfrm>
+          <a:prstGeom prst="straightConnector1">
+            <a:avLst/>
+          </a:prstGeom>
+          <a:ln>
+            <a:solidFill>
+              <a:schemeClr val="bg1"/>
+            </a:solidFill>
+            <a:tailEnd type="triangle"/>
+          </a:ln>
+        </p:spPr>
+        <p:style>
+          <a:lnRef idx="1">
+            <a:schemeClr val="accent1"/>
+          </a:lnRef>
+          <a:fillRef idx="0">
+            <a:schemeClr val="accent1"/>
+          </a:fillRef>
+          <a:effectRef idx="0">
+            <a:schemeClr val="accent1"/>
+          </a:effectRef>
+          <a:fontRef idx="minor">
+            <a:schemeClr val="tx1"/>
+          </a:fontRef>
+        </p:style>
+      </p:cxnSp>
+      <p:cxnSp>
+        <p:nvCxnSpPr>
+          <p:cNvPr id="10" name="Straight Arrow Connector 9">
+            <a:extLst>
+              <a:ext uri="{FF2B5EF4-FFF2-40B4-BE49-F238E27FC236}">
+                <a16:creationId xmlns:a16="http://schemas.microsoft.com/office/drawing/2014/main" id="{13959D86-2DF9-1051-0AFB-0DB938EA3FEF}"/>
+              </a:ext>
+            </a:extLst>
+          </p:cNvPr>
+          <p:cNvCxnSpPr/>
+          <p:nvPr/>
+        </p:nvCxnSpPr>
+        <p:spPr>
+          <a:xfrm flipV="1">
+            <a:off x="357051" y="3591482"/>
+            <a:ext cx="452846" cy="288119"/>
+          </a:xfrm>
+          <a:prstGeom prst="straightConnector1">
+            <a:avLst/>
+          </a:prstGeom>
+          <a:ln>
+            <a:solidFill>
+              <a:schemeClr val="bg1"/>
+            </a:solidFill>
+            <a:tailEnd type="triangle"/>
+          </a:ln>
+        </p:spPr>
+        <p:style>
+          <a:lnRef idx="1">
+            <a:schemeClr val="accent1"/>
+          </a:lnRef>
+          <a:fillRef idx="0">
+            <a:schemeClr val="accent1"/>
+          </a:fillRef>
+          <a:effectRef idx="0">
+            <a:schemeClr val="accent1"/>
+          </a:effectRef>
+          <a:fontRef idx="minor">
+            <a:schemeClr val="tx1"/>
+          </a:fontRef>
+        </p:style>
+      </p:cxnSp>
+      <p:sp>
+        <p:nvSpPr>
+          <p:cNvPr id="11" name="TextBox 10">
+            <a:extLst>
+              <a:ext uri="{FF2B5EF4-FFF2-40B4-BE49-F238E27FC236}">
+                <a16:creationId xmlns:a16="http://schemas.microsoft.com/office/drawing/2014/main" id="{8BE088C8-4127-A61F-2B98-4D26B229F2C8}"/>
+              </a:ext>
+            </a:extLst>
+          </p:cNvPr>
+          <p:cNvSpPr txBox="1"/>
+          <p:nvPr/>
+        </p:nvSpPr>
+        <p:spPr>
+          <a:xfrm>
+            <a:off x="55365" y="3729792"/>
+            <a:ext cx="301686" cy="369332"/>
+          </a:xfrm>
+          <a:prstGeom prst="rect">
+            <a:avLst/>
+          </a:prstGeom>
+          <a:noFill/>
+        </p:spPr>
+        <p:txBody>
+          <a:bodyPr wrap="none" rtlCol="0">
+            <a:spAutoFit/>
+          </a:bodyPr>
+          <a:lstStyle/>
+          <a:p>
+            <a:r>
+              <a:rPr lang="en-US" dirty="0">
+                <a:solidFill>
+                  <a:schemeClr val="bg1"/>
+                </a:solidFill>
+              </a:rPr>
+              <a:t>2</a:t>
+            </a:r>
+          </a:p>
+        </p:txBody>
+      </p:sp>
+      <p:cxnSp>
+        <p:nvCxnSpPr>
+          <p:cNvPr id="12" name="Straight Arrow Connector 11">
+            <a:extLst>
+              <a:ext uri="{FF2B5EF4-FFF2-40B4-BE49-F238E27FC236}">
+                <a16:creationId xmlns:a16="http://schemas.microsoft.com/office/drawing/2014/main" id="{B4FFF2CC-27DA-77FB-D1EE-0815F0897EC4}"/>
+              </a:ext>
+            </a:extLst>
+          </p:cNvPr>
+          <p:cNvCxnSpPr>
+            <a:cxnSpLocks/>
+          </p:cNvCxnSpPr>
+          <p:nvPr/>
+        </p:nvCxnSpPr>
+        <p:spPr>
+          <a:xfrm>
+            <a:off x="357051" y="5660959"/>
+            <a:ext cx="452846" cy="329891"/>
+          </a:xfrm>
+          <a:prstGeom prst="straightConnector1">
+            <a:avLst/>
+          </a:prstGeom>
+          <a:ln>
+            <a:solidFill>
+              <a:schemeClr val="bg1"/>
+            </a:solidFill>
+            <a:tailEnd type="triangle"/>
+          </a:ln>
+        </p:spPr>
+        <p:style>
+          <a:lnRef idx="1">
+            <a:schemeClr val="accent1"/>
+          </a:lnRef>
+          <a:fillRef idx="0">
+            <a:schemeClr val="accent1"/>
+          </a:fillRef>
+          <a:effectRef idx="0">
+            <a:schemeClr val="accent1"/>
+          </a:effectRef>
+          <a:fontRef idx="minor">
+            <a:schemeClr val="tx1"/>
+          </a:fontRef>
+        </p:style>
+      </p:cxnSp>
+      <p:cxnSp>
+        <p:nvCxnSpPr>
+          <p:cNvPr id="23" name="Straight Arrow Connector 22">
+            <a:extLst>
+              <a:ext uri="{FF2B5EF4-FFF2-40B4-BE49-F238E27FC236}">
+                <a16:creationId xmlns:a16="http://schemas.microsoft.com/office/drawing/2014/main" id="{9E33EDF5-10F3-BD89-436D-681A89509856}"/>
+              </a:ext>
+            </a:extLst>
+          </p:cNvPr>
+          <p:cNvCxnSpPr/>
+          <p:nvPr/>
+        </p:nvCxnSpPr>
+        <p:spPr>
+          <a:xfrm flipV="1">
+            <a:off x="357051" y="5272691"/>
+            <a:ext cx="452846" cy="288119"/>
+          </a:xfrm>
+          <a:prstGeom prst="straightConnector1">
+            <a:avLst/>
+          </a:prstGeom>
+          <a:ln>
+            <a:solidFill>
+              <a:schemeClr val="bg1"/>
+            </a:solidFill>
+            <a:tailEnd type="triangle"/>
+          </a:ln>
+        </p:spPr>
+        <p:style>
+          <a:lnRef idx="1">
+            <a:schemeClr val="accent1"/>
+          </a:lnRef>
+          <a:fillRef idx="0">
+            <a:schemeClr val="accent1"/>
+          </a:fillRef>
+          <a:effectRef idx="0">
+            <a:schemeClr val="accent1"/>
+          </a:effectRef>
+          <a:fontRef idx="minor">
+            <a:schemeClr val="tx1"/>
+          </a:fontRef>
+        </p:style>
+      </p:cxnSp>
+      <p:sp>
+        <p:nvSpPr>
+          <p:cNvPr id="24" name="TextBox 23">
+            <a:extLst>
+              <a:ext uri="{FF2B5EF4-FFF2-40B4-BE49-F238E27FC236}">
+                <a16:creationId xmlns:a16="http://schemas.microsoft.com/office/drawing/2014/main" id="{2A5E2A42-B531-AA6E-D889-E80F81135C2D}"/>
+              </a:ext>
+            </a:extLst>
+          </p:cNvPr>
+          <p:cNvSpPr txBox="1"/>
+          <p:nvPr/>
+        </p:nvSpPr>
+        <p:spPr>
+          <a:xfrm>
+            <a:off x="55365" y="5411001"/>
+            <a:ext cx="301686" cy="369332"/>
+          </a:xfrm>
+          <a:prstGeom prst="rect">
+            <a:avLst/>
+          </a:prstGeom>
+          <a:noFill/>
+        </p:spPr>
+        <p:txBody>
+          <a:bodyPr wrap="none" rtlCol="0">
+            <a:spAutoFit/>
+          </a:bodyPr>
+          <a:lstStyle/>
+          <a:p>
+            <a:r>
+              <a:rPr lang="en-US" dirty="0">
+                <a:solidFill>
+                  <a:schemeClr val="bg1"/>
+                </a:solidFill>
+              </a:rPr>
+              <a:t>3</a:t>
             </a:r>
           </a:p>
         </p:txBody>
@@ -15303,6 +16264,381 @@
           </a:p>
         </p:txBody>
       </p:sp>
+      <p:cxnSp>
+        <p:nvCxnSpPr>
+          <p:cNvPr id="2" name="Straight Arrow Connector 1">
+            <a:extLst>
+              <a:ext uri="{FF2B5EF4-FFF2-40B4-BE49-F238E27FC236}">
+                <a16:creationId xmlns:a16="http://schemas.microsoft.com/office/drawing/2014/main" id="{82C00D83-DA1D-A3BA-9F41-AB1BFF19265B}"/>
+              </a:ext>
+            </a:extLst>
+          </p:cNvPr>
+          <p:cNvCxnSpPr>
+            <a:cxnSpLocks/>
+          </p:cNvCxnSpPr>
+          <p:nvPr/>
+        </p:nvCxnSpPr>
+        <p:spPr>
+          <a:xfrm>
+            <a:off x="357051" y="2386149"/>
+            <a:ext cx="452846" cy="329891"/>
+          </a:xfrm>
+          <a:prstGeom prst="straightConnector1">
+            <a:avLst/>
+          </a:prstGeom>
+          <a:ln>
+            <a:solidFill>
+              <a:schemeClr val="bg1"/>
+            </a:solidFill>
+            <a:tailEnd type="triangle"/>
+          </a:ln>
+        </p:spPr>
+        <p:style>
+          <a:lnRef idx="1">
+            <a:schemeClr val="accent1"/>
+          </a:lnRef>
+          <a:fillRef idx="0">
+            <a:schemeClr val="accent1"/>
+          </a:fillRef>
+          <a:effectRef idx="0">
+            <a:schemeClr val="accent1"/>
+          </a:effectRef>
+          <a:fontRef idx="minor">
+            <a:schemeClr val="tx1"/>
+          </a:fontRef>
+        </p:style>
+      </p:cxnSp>
+      <p:cxnSp>
+        <p:nvCxnSpPr>
+          <p:cNvPr id="3" name="Straight Arrow Connector 2">
+            <a:extLst>
+              <a:ext uri="{FF2B5EF4-FFF2-40B4-BE49-F238E27FC236}">
+                <a16:creationId xmlns:a16="http://schemas.microsoft.com/office/drawing/2014/main" id="{BA4CB984-03F8-DC43-CBA9-D7D9981F5BA8}"/>
+              </a:ext>
+            </a:extLst>
+          </p:cNvPr>
+          <p:cNvCxnSpPr/>
+          <p:nvPr/>
+        </p:nvCxnSpPr>
+        <p:spPr>
+          <a:xfrm flipV="1">
+            <a:off x="357051" y="1997881"/>
+            <a:ext cx="452846" cy="288119"/>
+          </a:xfrm>
+          <a:prstGeom prst="straightConnector1">
+            <a:avLst/>
+          </a:prstGeom>
+          <a:ln>
+            <a:solidFill>
+              <a:schemeClr val="bg1"/>
+            </a:solidFill>
+            <a:tailEnd type="triangle"/>
+          </a:ln>
+        </p:spPr>
+        <p:style>
+          <a:lnRef idx="1">
+            <a:schemeClr val="accent1"/>
+          </a:lnRef>
+          <a:fillRef idx="0">
+            <a:schemeClr val="accent1"/>
+          </a:fillRef>
+          <a:effectRef idx="0">
+            <a:schemeClr val="accent1"/>
+          </a:effectRef>
+          <a:fontRef idx="minor">
+            <a:schemeClr val="tx1"/>
+          </a:fontRef>
+        </p:style>
+      </p:cxnSp>
+      <p:sp>
+        <p:nvSpPr>
+          <p:cNvPr id="4" name="TextBox 3">
+            <a:extLst>
+              <a:ext uri="{FF2B5EF4-FFF2-40B4-BE49-F238E27FC236}">
+                <a16:creationId xmlns:a16="http://schemas.microsoft.com/office/drawing/2014/main" id="{378E6F8B-7E4E-9905-DA72-52FD1415D468}"/>
+              </a:ext>
+            </a:extLst>
+          </p:cNvPr>
+          <p:cNvSpPr txBox="1"/>
+          <p:nvPr/>
+        </p:nvSpPr>
+        <p:spPr>
+          <a:xfrm>
+            <a:off x="55365" y="2136191"/>
+            <a:ext cx="301686" cy="369332"/>
+          </a:xfrm>
+          <a:prstGeom prst="rect">
+            <a:avLst/>
+          </a:prstGeom>
+          <a:noFill/>
+        </p:spPr>
+        <p:txBody>
+          <a:bodyPr wrap="none" rtlCol="0">
+            <a:spAutoFit/>
+          </a:bodyPr>
+          <a:lstStyle/>
+          <a:p>
+            <a:r>
+              <a:rPr lang="en-US" dirty="0">
+                <a:solidFill>
+                  <a:schemeClr val="bg1"/>
+                </a:solidFill>
+              </a:rPr>
+              <a:t>1</a:t>
+            </a:r>
+          </a:p>
+        </p:txBody>
+      </p:sp>
+      <p:cxnSp>
+        <p:nvCxnSpPr>
+          <p:cNvPr id="5" name="Straight Arrow Connector 4">
+            <a:extLst>
+              <a:ext uri="{FF2B5EF4-FFF2-40B4-BE49-F238E27FC236}">
+                <a16:creationId xmlns:a16="http://schemas.microsoft.com/office/drawing/2014/main" id="{3A01363E-8F17-5D4F-05FE-55AA75D99D05}"/>
+              </a:ext>
+            </a:extLst>
+          </p:cNvPr>
+          <p:cNvCxnSpPr>
+            <a:cxnSpLocks/>
+          </p:cNvCxnSpPr>
+          <p:nvPr/>
+        </p:nvCxnSpPr>
+        <p:spPr>
+          <a:xfrm>
+            <a:off x="357051" y="3979750"/>
+            <a:ext cx="452846" cy="329891"/>
+          </a:xfrm>
+          <a:prstGeom prst="straightConnector1">
+            <a:avLst/>
+          </a:prstGeom>
+          <a:ln>
+            <a:solidFill>
+              <a:schemeClr val="bg1"/>
+            </a:solidFill>
+            <a:tailEnd type="triangle"/>
+          </a:ln>
+        </p:spPr>
+        <p:style>
+          <a:lnRef idx="1">
+            <a:schemeClr val="accent1"/>
+          </a:lnRef>
+          <a:fillRef idx="0">
+            <a:schemeClr val="accent1"/>
+          </a:fillRef>
+          <a:effectRef idx="0">
+            <a:schemeClr val="accent1"/>
+          </a:effectRef>
+          <a:fontRef idx="minor">
+            <a:schemeClr val="tx1"/>
+          </a:fontRef>
+        </p:style>
+      </p:cxnSp>
+      <p:cxnSp>
+        <p:nvCxnSpPr>
+          <p:cNvPr id="7" name="Straight Arrow Connector 6">
+            <a:extLst>
+              <a:ext uri="{FF2B5EF4-FFF2-40B4-BE49-F238E27FC236}">
+                <a16:creationId xmlns:a16="http://schemas.microsoft.com/office/drawing/2014/main" id="{91AD7180-2AED-A5B0-8A50-BD2CB5C41EA4}"/>
+              </a:ext>
+            </a:extLst>
+          </p:cNvPr>
+          <p:cNvCxnSpPr/>
+          <p:nvPr/>
+        </p:nvCxnSpPr>
+        <p:spPr>
+          <a:xfrm flipV="1">
+            <a:off x="357051" y="3591482"/>
+            <a:ext cx="452846" cy="288119"/>
+          </a:xfrm>
+          <a:prstGeom prst="straightConnector1">
+            <a:avLst/>
+          </a:prstGeom>
+          <a:ln>
+            <a:solidFill>
+              <a:schemeClr val="bg1"/>
+            </a:solidFill>
+            <a:tailEnd type="triangle"/>
+          </a:ln>
+        </p:spPr>
+        <p:style>
+          <a:lnRef idx="1">
+            <a:schemeClr val="accent1"/>
+          </a:lnRef>
+          <a:fillRef idx="0">
+            <a:schemeClr val="accent1"/>
+          </a:fillRef>
+          <a:effectRef idx="0">
+            <a:schemeClr val="accent1"/>
+          </a:effectRef>
+          <a:fontRef idx="minor">
+            <a:schemeClr val="tx1"/>
+          </a:fontRef>
+        </p:style>
+      </p:cxnSp>
+      <p:sp>
+        <p:nvSpPr>
+          <p:cNvPr id="8" name="TextBox 7">
+            <a:extLst>
+              <a:ext uri="{FF2B5EF4-FFF2-40B4-BE49-F238E27FC236}">
+                <a16:creationId xmlns:a16="http://schemas.microsoft.com/office/drawing/2014/main" id="{B76FB233-DD93-AD76-A0B1-F6D5CD1C4028}"/>
+              </a:ext>
+            </a:extLst>
+          </p:cNvPr>
+          <p:cNvSpPr txBox="1"/>
+          <p:nvPr/>
+        </p:nvSpPr>
+        <p:spPr>
+          <a:xfrm>
+            <a:off x="55365" y="3729792"/>
+            <a:ext cx="301686" cy="369332"/>
+          </a:xfrm>
+          <a:prstGeom prst="rect">
+            <a:avLst/>
+          </a:prstGeom>
+          <a:noFill/>
+        </p:spPr>
+        <p:txBody>
+          <a:bodyPr wrap="none" rtlCol="0">
+            <a:spAutoFit/>
+          </a:bodyPr>
+          <a:lstStyle/>
+          <a:p>
+            <a:r>
+              <a:rPr lang="en-US" dirty="0">
+                <a:solidFill>
+                  <a:schemeClr val="bg1"/>
+                </a:solidFill>
+              </a:rPr>
+              <a:t>2</a:t>
+            </a:r>
+          </a:p>
+        </p:txBody>
+      </p:sp>
+      <p:cxnSp>
+        <p:nvCxnSpPr>
+          <p:cNvPr id="9" name="Straight Arrow Connector 8">
+            <a:extLst>
+              <a:ext uri="{FF2B5EF4-FFF2-40B4-BE49-F238E27FC236}">
+                <a16:creationId xmlns:a16="http://schemas.microsoft.com/office/drawing/2014/main" id="{E6876D88-5043-BB88-1FDC-CCDFCB01FD11}"/>
+              </a:ext>
+            </a:extLst>
+          </p:cNvPr>
+          <p:cNvCxnSpPr>
+            <a:cxnSpLocks/>
+          </p:cNvCxnSpPr>
+          <p:nvPr/>
+        </p:nvCxnSpPr>
+        <p:spPr>
+          <a:xfrm>
+            <a:off x="357051" y="5660959"/>
+            <a:ext cx="452846" cy="329891"/>
+          </a:xfrm>
+          <a:prstGeom prst="straightConnector1">
+            <a:avLst/>
+          </a:prstGeom>
+          <a:ln>
+            <a:solidFill>
+              <a:schemeClr val="bg1"/>
+            </a:solidFill>
+            <a:tailEnd type="triangle"/>
+          </a:ln>
+        </p:spPr>
+        <p:style>
+          <a:lnRef idx="1">
+            <a:schemeClr val="accent1"/>
+          </a:lnRef>
+          <a:fillRef idx="0">
+            <a:schemeClr val="accent1"/>
+          </a:fillRef>
+          <a:effectRef idx="0">
+            <a:schemeClr val="accent1"/>
+          </a:effectRef>
+          <a:fontRef idx="minor">
+            <a:schemeClr val="tx1"/>
+          </a:fontRef>
+        </p:style>
+      </p:cxnSp>
+      <p:cxnSp>
+        <p:nvCxnSpPr>
+          <p:cNvPr id="10" name="Straight Arrow Connector 9">
+            <a:extLst>
+              <a:ext uri="{FF2B5EF4-FFF2-40B4-BE49-F238E27FC236}">
+                <a16:creationId xmlns:a16="http://schemas.microsoft.com/office/drawing/2014/main" id="{49E4DE31-FBE5-C0C6-66DD-63BF873C58F0}"/>
+              </a:ext>
+            </a:extLst>
+          </p:cNvPr>
+          <p:cNvCxnSpPr/>
+          <p:nvPr/>
+        </p:nvCxnSpPr>
+        <p:spPr>
+          <a:xfrm flipV="1">
+            <a:off x="357051" y="5272691"/>
+            <a:ext cx="452846" cy="288119"/>
+          </a:xfrm>
+          <a:prstGeom prst="straightConnector1">
+            <a:avLst/>
+          </a:prstGeom>
+          <a:ln>
+            <a:solidFill>
+              <a:schemeClr val="bg1"/>
+            </a:solidFill>
+            <a:tailEnd type="triangle"/>
+          </a:ln>
+        </p:spPr>
+        <p:style>
+          <a:lnRef idx="1">
+            <a:schemeClr val="accent1"/>
+          </a:lnRef>
+          <a:fillRef idx="0">
+            <a:schemeClr val="accent1"/>
+          </a:fillRef>
+          <a:effectRef idx="0">
+            <a:schemeClr val="accent1"/>
+          </a:effectRef>
+          <a:fontRef idx="minor">
+            <a:schemeClr val="tx1"/>
+          </a:fontRef>
+        </p:style>
+      </p:cxnSp>
+      <p:sp>
+        <p:nvSpPr>
+          <p:cNvPr id="11" name="TextBox 10">
+            <a:extLst>
+              <a:ext uri="{FF2B5EF4-FFF2-40B4-BE49-F238E27FC236}">
+                <a16:creationId xmlns:a16="http://schemas.microsoft.com/office/drawing/2014/main" id="{18F8292E-4538-F51E-E48B-A57A07896BE7}"/>
+              </a:ext>
+            </a:extLst>
+          </p:cNvPr>
+          <p:cNvSpPr txBox="1"/>
+          <p:nvPr/>
+        </p:nvSpPr>
+        <p:spPr>
+          <a:xfrm>
+            <a:off x="55365" y="5411001"/>
+            <a:ext cx="301686" cy="369332"/>
+          </a:xfrm>
+          <a:prstGeom prst="rect">
+            <a:avLst/>
+          </a:prstGeom>
+          <a:noFill/>
+        </p:spPr>
+        <p:txBody>
+          <a:bodyPr wrap="none" rtlCol="0">
+            <a:spAutoFit/>
+          </a:bodyPr>
+          <a:lstStyle/>
+          <a:p>
+            <a:r>
+              <a:rPr lang="en-US" dirty="0">
+                <a:solidFill>
+                  <a:schemeClr val="bg1"/>
+                </a:solidFill>
+              </a:rPr>
+              <a:t>3</a:t>
+            </a:r>
+          </a:p>
+        </p:txBody>
+      </p:sp>
     </p:spTree>
     <p:extLst>
       <p:ext uri="{BB962C8B-B14F-4D97-AF65-F5344CB8AC3E}">
@@ -15377,8 +16713,8 @@
         </p:nvSpPr>
         <p:spPr>
           <a:xfrm>
-            <a:off x="964194" y="3299988"/>
-            <a:ext cx="4617267" cy="570368"/>
+            <a:off x="964194" y="3238500"/>
+            <a:ext cx="4617267" cy="631855"/>
           </a:xfrm>
           <a:prstGeom prst="rect">
             <a:avLst/>
@@ -15973,6 +17309,381 @@
 Result
 Physical X/Y switches establish gantry coordinates.
 Toolhead stays at LIFT_HOME.</a:t>
+            </a:r>
+          </a:p>
+        </p:txBody>
+      </p:sp>
+      <p:cxnSp>
+        <p:nvCxnSpPr>
+          <p:cNvPr id="2" name="Straight Arrow Connector 1">
+            <a:extLst>
+              <a:ext uri="{FF2B5EF4-FFF2-40B4-BE49-F238E27FC236}">
+                <a16:creationId xmlns:a16="http://schemas.microsoft.com/office/drawing/2014/main" id="{4EA07165-00BF-A104-93DF-67EFB253BD0B}"/>
+              </a:ext>
+            </a:extLst>
+          </p:cNvPr>
+          <p:cNvCxnSpPr>
+            <a:cxnSpLocks/>
+          </p:cNvCxnSpPr>
+          <p:nvPr/>
+        </p:nvCxnSpPr>
+        <p:spPr>
+          <a:xfrm>
+            <a:off x="357051" y="2386149"/>
+            <a:ext cx="452846" cy="329891"/>
+          </a:xfrm>
+          <a:prstGeom prst="straightConnector1">
+            <a:avLst/>
+          </a:prstGeom>
+          <a:ln>
+            <a:solidFill>
+              <a:schemeClr val="bg1"/>
+            </a:solidFill>
+            <a:tailEnd type="triangle"/>
+          </a:ln>
+        </p:spPr>
+        <p:style>
+          <a:lnRef idx="1">
+            <a:schemeClr val="accent1"/>
+          </a:lnRef>
+          <a:fillRef idx="0">
+            <a:schemeClr val="accent1"/>
+          </a:fillRef>
+          <a:effectRef idx="0">
+            <a:schemeClr val="accent1"/>
+          </a:effectRef>
+          <a:fontRef idx="minor">
+            <a:schemeClr val="tx1"/>
+          </a:fontRef>
+        </p:style>
+      </p:cxnSp>
+      <p:cxnSp>
+        <p:nvCxnSpPr>
+          <p:cNvPr id="3" name="Straight Arrow Connector 2">
+            <a:extLst>
+              <a:ext uri="{FF2B5EF4-FFF2-40B4-BE49-F238E27FC236}">
+                <a16:creationId xmlns:a16="http://schemas.microsoft.com/office/drawing/2014/main" id="{3DD21CD7-5FEB-36CE-32EF-74683A372A15}"/>
+              </a:ext>
+            </a:extLst>
+          </p:cNvPr>
+          <p:cNvCxnSpPr/>
+          <p:nvPr/>
+        </p:nvCxnSpPr>
+        <p:spPr>
+          <a:xfrm flipV="1">
+            <a:off x="357051" y="1997881"/>
+            <a:ext cx="452846" cy="288119"/>
+          </a:xfrm>
+          <a:prstGeom prst="straightConnector1">
+            <a:avLst/>
+          </a:prstGeom>
+          <a:ln>
+            <a:solidFill>
+              <a:schemeClr val="bg1"/>
+            </a:solidFill>
+            <a:tailEnd type="triangle"/>
+          </a:ln>
+        </p:spPr>
+        <p:style>
+          <a:lnRef idx="1">
+            <a:schemeClr val="accent1"/>
+          </a:lnRef>
+          <a:fillRef idx="0">
+            <a:schemeClr val="accent1"/>
+          </a:fillRef>
+          <a:effectRef idx="0">
+            <a:schemeClr val="accent1"/>
+          </a:effectRef>
+          <a:fontRef idx="minor">
+            <a:schemeClr val="tx1"/>
+          </a:fontRef>
+        </p:style>
+      </p:cxnSp>
+      <p:sp>
+        <p:nvSpPr>
+          <p:cNvPr id="4" name="TextBox 3">
+            <a:extLst>
+              <a:ext uri="{FF2B5EF4-FFF2-40B4-BE49-F238E27FC236}">
+                <a16:creationId xmlns:a16="http://schemas.microsoft.com/office/drawing/2014/main" id="{230EB072-21D9-C34A-8F01-65F72D40E1C9}"/>
+              </a:ext>
+            </a:extLst>
+          </p:cNvPr>
+          <p:cNvSpPr txBox="1"/>
+          <p:nvPr/>
+        </p:nvSpPr>
+        <p:spPr>
+          <a:xfrm>
+            <a:off x="55365" y="2136191"/>
+            <a:ext cx="301686" cy="369332"/>
+          </a:xfrm>
+          <a:prstGeom prst="rect">
+            <a:avLst/>
+          </a:prstGeom>
+          <a:noFill/>
+        </p:spPr>
+        <p:txBody>
+          <a:bodyPr wrap="none" rtlCol="0">
+            <a:spAutoFit/>
+          </a:bodyPr>
+          <a:lstStyle/>
+          <a:p>
+            <a:r>
+              <a:rPr lang="en-US" dirty="0">
+                <a:solidFill>
+                  <a:schemeClr val="bg1"/>
+                </a:solidFill>
+              </a:rPr>
+              <a:t>1</a:t>
+            </a:r>
+          </a:p>
+        </p:txBody>
+      </p:sp>
+      <p:cxnSp>
+        <p:nvCxnSpPr>
+          <p:cNvPr id="5" name="Straight Arrow Connector 4">
+            <a:extLst>
+              <a:ext uri="{FF2B5EF4-FFF2-40B4-BE49-F238E27FC236}">
+                <a16:creationId xmlns:a16="http://schemas.microsoft.com/office/drawing/2014/main" id="{3A619823-5BE3-E59C-DF97-57BE1BFF3BAD}"/>
+              </a:ext>
+            </a:extLst>
+          </p:cNvPr>
+          <p:cNvCxnSpPr>
+            <a:cxnSpLocks/>
+          </p:cNvCxnSpPr>
+          <p:nvPr/>
+        </p:nvCxnSpPr>
+        <p:spPr>
+          <a:xfrm>
+            <a:off x="357051" y="3979750"/>
+            <a:ext cx="452846" cy="329891"/>
+          </a:xfrm>
+          <a:prstGeom prst="straightConnector1">
+            <a:avLst/>
+          </a:prstGeom>
+          <a:ln>
+            <a:solidFill>
+              <a:schemeClr val="bg1"/>
+            </a:solidFill>
+            <a:tailEnd type="triangle"/>
+          </a:ln>
+        </p:spPr>
+        <p:style>
+          <a:lnRef idx="1">
+            <a:schemeClr val="accent1"/>
+          </a:lnRef>
+          <a:fillRef idx="0">
+            <a:schemeClr val="accent1"/>
+          </a:fillRef>
+          <a:effectRef idx="0">
+            <a:schemeClr val="accent1"/>
+          </a:effectRef>
+          <a:fontRef idx="minor">
+            <a:schemeClr val="tx1"/>
+          </a:fontRef>
+        </p:style>
+      </p:cxnSp>
+      <p:cxnSp>
+        <p:nvCxnSpPr>
+          <p:cNvPr id="7" name="Straight Arrow Connector 6">
+            <a:extLst>
+              <a:ext uri="{FF2B5EF4-FFF2-40B4-BE49-F238E27FC236}">
+                <a16:creationId xmlns:a16="http://schemas.microsoft.com/office/drawing/2014/main" id="{70F7F360-204E-8E9F-1499-23DB78899DB2}"/>
+              </a:ext>
+            </a:extLst>
+          </p:cNvPr>
+          <p:cNvCxnSpPr/>
+          <p:nvPr/>
+        </p:nvCxnSpPr>
+        <p:spPr>
+          <a:xfrm flipV="1">
+            <a:off x="357051" y="3591482"/>
+            <a:ext cx="452846" cy="288119"/>
+          </a:xfrm>
+          <a:prstGeom prst="straightConnector1">
+            <a:avLst/>
+          </a:prstGeom>
+          <a:ln>
+            <a:solidFill>
+              <a:schemeClr val="bg1"/>
+            </a:solidFill>
+            <a:tailEnd type="triangle"/>
+          </a:ln>
+        </p:spPr>
+        <p:style>
+          <a:lnRef idx="1">
+            <a:schemeClr val="accent1"/>
+          </a:lnRef>
+          <a:fillRef idx="0">
+            <a:schemeClr val="accent1"/>
+          </a:fillRef>
+          <a:effectRef idx="0">
+            <a:schemeClr val="accent1"/>
+          </a:effectRef>
+          <a:fontRef idx="minor">
+            <a:schemeClr val="tx1"/>
+          </a:fontRef>
+        </p:style>
+      </p:cxnSp>
+      <p:sp>
+        <p:nvSpPr>
+          <p:cNvPr id="8" name="TextBox 7">
+            <a:extLst>
+              <a:ext uri="{FF2B5EF4-FFF2-40B4-BE49-F238E27FC236}">
+                <a16:creationId xmlns:a16="http://schemas.microsoft.com/office/drawing/2014/main" id="{8821EB6B-2A32-5B2F-BCB4-5C9D45304D7C}"/>
+              </a:ext>
+            </a:extLst>
+          </p:cNvPr>
+          <p:cNvSpPr txBox="1"/>
+          <p:nvPr/>
+        </p:nvSpPr>
+        <p:spPr>
+          <a:xfrm>
+            <a:off x="55365" y="3729792"/>
+            <a:ext cx="301686" cy="369332"/>
+          </a:xfrm>
+          <a:prstGeom prst="rect">
+            <a:avLst/>
+          </a:prstGeom>
+          <a:noFill/>
+        </p:spPr>
+        <p:txBody>
+          <a:bodyPr wrap="none" rtlCol="0">
+            <a:spAutoFit/>
+          </a:bodyPr>
+          <a:lstStyle/>
+          <a:p>
+            <a:r>
+              <a:rPr lang="en-US" dirty="0">
+                <a:solidFill>
+                  <a:schemeClr val="bg1"/>
+                </a:solidFill>
+              </a:rPr>
+              <a:t>2</a:t>
+            </a:r>
+          </a:p>
+        </p:txBody>
+      </p:sp>
+      <p:cxnSp>
+        <p:nvCxnSpPr>
+          <p:cNvPr id="9" name="Straight Arrow Connector 8">
+            <a:extLst>
+              <a:ext uri="{FF2B5EF4-FFF2-40B4-BE49-F238E27FC236}">
+                <a16:creationId xmlns:a16="http://schemas.microsoft.com/office/drawing/2014/main" id="{165FF3F6-7996-4A78-3BA6-EF0784C4714A}"/>
+              </a:ext>
+            </a:extLst>
+          </p:cNvPr>
+          <p:cNvCxnSpPr>
+            <a:cxnSpLocks/>
+          </p:cNvCxnSpPr>
+          <p:nvPr/>
+        </p:nvCxnSpPr>
+        <p:spPr>
+          <a:xfrm>
+            <a:off x="357051" y="5660959"/>
+            <a:ext cx="452846" cy="329891"/>
+          </a:xfrm>
+          <a:prstGeom prst="straightConnector1">
+            <a:avLst/>
+          </a:prstGeom>
+          <a:ln>
+            <a:solidFill>
+              <a:schemeClr val="bg1"/>
+            </a:solidFill>
+            <a:tailEnd type="triangle"/>
+          </a:ln>
+        </p:spPr>
+        <p:style>
+          <a:lnRef idx="1">
+            <a:schemeClr val="accent1"/>
+          </a:lnRef>
+          <a:fillRef idx="0">
+            <a:schemeClr val="accent1"/>
+          </a:fillRef>
+          <a:effectRef idx="0">
+            <a:schemeClr val="accent1"/>
+          </a:effectRef>
+          <a:fontRef idx="minor">
+            <a:schemeClr val="tx1"/>
+          </a:fontRef>
+        </p:style>
+      </p:cxnSp>
+      <p:cxnSp>
+        <p:nvCxnSpPr>
+          <p:cNvPr id="10" name="Straight Arrow Connector 9">
+            <a:extLst>
+              <a:ext uri="{FF2B5EF4-FFF2-40B4-BE49-F238E27FC236}">
+                <a16:creationId xmlns:a16="http://schemas.microsoft.com/office/drawing/2014/main" id="{1F40209D-350B-E1DD-CC23-1AA20552578C}"/>
+              </a:ext>
+            </a:extLst>
+          </p:cNvPr>
+          <p:cNvCxnSpPr/>
+          <p:nvPr/>
+        </p:nvCxnSpPr>
+        <p:spPr>
+          <a:xfrm flipV="1">
+            <a:off x="357051" y="5272691"/>
+            <a:ext cx="452846" cy="288119"/>
+          </a:xfrm>
+          <a:prstGeom prst="straightConnector1">
+            <a:avLst/>
+          </a:prstGeom>
+          <a:ln>
+            <a:solidFill>
+              <a:schemeClr val="bg1"/>
+            </a:solidFill>
+            <a:tailEnd type="triangle"/>
+          </a:ln>
+        </p:spPr>
+        <p:style>
+          <a:lnRef idx="1">
+            <a:schemeClr val="accent1"/>
+          </a:lnRef>
+          <a:fillRef idx="0">
+            <a:schemeClr val="accent1"/>
+          </a:fillRef>
+          <a:effectRef idx="0">
+            <a:schemeClr val="accent1"/>
+          </a:effectRef>
+          <a:fontRef idx="minor">
+            <a:schemeClr val="tx1"/>
+          </a:fontRef>
+        </p:style>
+      </p:cxnSp>
+      <p:sp>
+        <p:nvSpPr>
+          <p:cNvPr id="11" name="TextBox 10">
+            <a:extLst>
+              <a:ext uri="{FF2B5EF4-FFF2-40B4-BE49-F238E27FC236}">
+                <a16:creationId xmlns:a16="http://schemas.microsoft.com/office/drawing/2014/main" id="{2E5A00D3-7EA6-B128-6554-D6CBF4B40969}"/>
+              </a:ext>
+            </a:extLst>
+          </p:cNvPr>
+          <p:cNvSpPr txBox="1"/>
+          <p:nvPr/>
+        </p:nvSpPr>
+        <p:spPr>
+          <a:xfrm>
+            <a:off x="55365" y="5411001"/>
+            <a:ext cx="301686" cy="369332"/>
+          </a:xfrm>
+          <a:prstGeom prst="rect">
+            <a:avLst/>
+          </a:prstGeom>
+          <a:noFill/>
+        </p:spPr>
+        <p:txBody>
+          <a:bodyPr wrap="none" rtlCol="0">
+            <a:spAutoFit/>
+          </a:bodyPr>
+          <a:lstStyle/>
+          <a:p>
+            <a:r>
+              <a:rPr lang="en-US" dirty="0">
+                <a:solidFill>
+                  <a:schemeClr val="bg1"/>
+                </a:solidFill>
+              </a:rPr>
+              <a:t>3</a:t>
             </a:r>
           </a:p>
         </p:txBody>
@@ -16051,8 +17762,8 @@
         </p:nvSpPr>
         <p:spPr>
           <a:xfrm>
-            <a:off x="964194" y="4141960"/>
-            <a:ext cx="4617267" cy="570368"/>
+            <a:off x="964194" y="4038600"/>
+            <a:ext cx="4617267" cy="619125"/>
           </a:xfrm>
           <a:prstGeom prst="rect">
             <a:avLst/>
@@ -16647,6 +18358,381 @@
 Result
 Center magnet sets G54 X/Y zero.
 Outer magnet sets A zero.</a:t>
+            </a:r>
+          </a:p>
+        </p:txBody>
+      </p:sp>
+      <p:cxnSp>
+        <p:nvCxnSpPr>
+          <p:cNvPr id="2" name="Straight Arrow Connector 1">
+            <a:extLst>
+              <a:ext uri="{FF2B5EF4-FFF2-40B4-BE49-F238E27FC236}">
+                <a16:creationId xmlns:a16="http://schemas.microsoft.com/office/drawing/2014/main" id="{561047B3-EC78-A4E7-3D8B-863808F78367}"/>
+              </a:ext>
+            </a:extLst>
+          </p:cNvPr>
+          <p:cNvCxnSpPr>
+            <a:cxnSpLocks/>
+          </p:cNvCxnSpPr>
+          <p:nvPr/>
+        </p:nvCxnSpPr>
+        <p:spPr>
+          <a:xfrm>
+            <a:off x="357051" y="2386149"/>
+            <a:ext cx="452846" cy="329891"/>
+          </a:xfrm>
+          <a:prstGeom prst="straightConnector1">
+            <a:avLst/>
+          </a:prstGeom>
+          <a:ln>
+            <a:solidFill>
+              <a:schemeClr val="bg1"/>
+            </a:solidFill>
+            <a:tailEnd type="triangle"/>
+          </a:ln>
+        </p:spPr>
+        <p:style>
+          <a:lnRef idx="1">
+            <a:schemeClr val="accent1"/>
+          </a:lnRef>
+          <a:fillRef idx="0">
+            <a:schemeClr val="accent1"/>
+          </a:fillRef>
+          <a:effectRef idx="0">
+            <a:schemeClr val="accent1"/>
+          </a:effectRef>
+          <a:fontRef idx="minor">
+            <a:schemeClr val="tx1"/>
+          </a:fontRef>
+        </p:style>
+      </p:cxnSp>
+      <p:cxnSp>
+        <p:nvCxnSpPr>
+          <p:cNvPr id="3" name="Straight Arrow Connector 2">
+            <a:extLst>
+              <a:ext uri="{FF2B5EF4-FFF2-40B4-BE49-F238E27FC236}">
+                <a16:creationId xmlns:a16="http://schemas.microsoft.com/office/drawing/2014/main" id="{5EE068E9-7BB2-35E3-BEA4-9B6A7F7E7DFF}"/>
+              </a:ext>
+            </a:extLst>
+          </p:cNvPr>
+          <p:cNvCxnSpPr/>
+          <p:nvPr/>
+        </p:nvCxnSpPr>
+        <p:spPr>
+          <a:xfrm flipV="1">
+            <a:off x="357051" y="1997881"/>
+            <a:ext cx="452846" cy="288119"/>
+          </a:xfrm>
+          <a:prstGeom prst="straightConnector1">
+            <a:avLst/>
+          </a:prstGeom>
+          <a:ln>
+            <a:solidFill>
+              <a:schemeClr val="bg1"/>
+            </a:solidFill>
+            <a:tailEnd type="triangle"/>
+          </a:ln>
+        </p:spPr>
+        <p:style>
+          <a:lnRef idx="1">
+            <a:schemeClr val="accent1"/>
+          </a:lnRef>
+          <a:fillRef idx="0">
+            <a:schemeClr val="accent1"/>
+          </a:fillRef>
+          <a:effectRef idx="0">
+            <a:schemeClr val="accent1"/>
+          </a:effectRef>
+          <a:fontRef idx="minor">
+            <a:schemeClr val="tx1"/>
+          </a:fontRef>
+        </p:style>
+      </p:cxnSp>
+      <p:sp>
+        <p:nvSpPr>
+          <p:cNvPr id="4" name="TextBox 3">
+            <a:extLst>
+              <a:ext uri="{FF2B5EF4-FFF2-40B4-BE49-F238E27FC236}">
+                <a16:creationId xmlns:a16="http://schemas.microsoft.com/office/drawing/2014/main" id="{F9C192F8-F8FA-D681-68A6-F321B15B19E3}"/>
+              </a:ext>
+            </a:extLst>
+          </p:cNvPr>
+          <p:cNvSpPr txBox="1"/>
+          <p:nvPr/>
+        </p:nvSpPr>
+        <p:spPr>
+          <a:xfrm>
+            <a:off x="55365" y="2136191"/>
+            <a:ext cx="301686" cy="369332"/>
+          </a:xfrm>
+          <a:prstGeom prst="rect">
+            <a:avLst/>
+          </a:prstGeom>
+          <a:noFill/>
+        </p:spPr>
+        <p:txBody>
+          <a:bodyPr wrap="none" rtlCol="0">
+            <a:spAutoFit/>
+          </a:bodyPr>
+          <a:lstStyle/>
+          <a:p>
+            <a:r>
+              <a:rPr lang="en-US" dirty="0">
+                <a:solidFill>
+                  <a:schemeClr val="bg1"/>
+                </a:solidFill>
+              </a:rPr>
+              <a:t>1</a:t>
+            </a:r>
+          </a:p>
+        </p:txBody>
+      </p:sp>
+      <p:cxnSp>
+        <p:nvCxnSpPr>
+          <p:cNvPr id="5" name="Straight Arrow Connector 4">
+            <a:extLst>
+              <a:ext uri="{FF2B5EF4-FFF2-40B4-BE49-F238E27FC236}">
+                <a16:creationId xmlns:a16="http://schemas.microsoft.com/office/drawing/2014/main" id="{8BD3D482-0DCF-C6D6-2F67-C853DDFC7F35}"/>
+              </a:ext>
+            </a:extLst>
+          </p:cNvPr>
+          <p:cNvCxnSpPr>
+            <a:cxnSpLocks/>
+          </p:cNvCxnSpPr>
+          <p:nvPr/>
+        </p:nvCxnSpPr>
+        <p:spPr>
+          <a:xfrm>
+            <a:off x="357051" y="3979750"/>
+            <a:ext cx="452846" cy="329891"/>
+          </a:xfrm>
+          <a:prstGeom prst="straightConnector1">
+            <a:avLst/>
+          </a:prstGeom>
+          <a:ln>
+            <a:solidFill>
+              <a:schemeClr val="bg1"/>
+            </a:solidFill>
+            <a:tailEnd type="triangle"/>
+          </a:ln>
+        </p:spPr>
+        <p:style>
+          <a:lnRef idx="1">
+            <a:schemeClr val="accent1"/>
+          </a:lnRef>
+          <a:fillRef idx="0">
+            <a:schemeClr val="accent1"/>
+          </a:fillRef>
+          <a:effectRef idx="0">
+            <a:schemeClr val="accent1"/>
+          </a:effectRef>
+          <a:fontRef idx="minor">
+            <a:schemeClr val="tx1"/>
+          </a:fontRef>
+        </p:style>
+      </p:cxnSp>
+      <p:cxnSp>
+        <p:nvCxnSpPr>
+          <p:cNvPr id="7" name="Straight Arrow Connector 6">
+            <a:extLst>
+              <a:ext uri="{FF2B5EF4-FFF2-40B4-BE49-F238E27FC236}">
+                <a16:creationId xmlns:a16="http://schemas.microsoft.com/office/drawing/2014/main" id="{E243C0A0-AE11-A612-0CDD-EA844B26212C}"/>
+              </a:ext>
+            </a:extLst>
+          </p:cNvPr>
+          <p:cNvCxnSpPr/>
+          <p:nvPr/>
+        </p:nvCxnSpPr>
+        <p:spPr>
+          <a:xfrm flipV="1">
+            <a:off x="357051" y="3591482"/>
+            <a:ext cx="452846" cy="288119"/>
+          </a:xfrm>
+          <a:prstGeom prst="straightConnector1">
+            <a:avLst/>
+          </a:prstGeom>
+          <a:ln>
+            <a:solidFill>
+              <a:schemeClr val="bg1"/>
+            </a:solidFill>
+            <a:tailEnd type="triangle"/>
+          </a:ln>
+        </p:spPr>
+        <p:style>
+          <a:lnRef idx="1">
+            <a:schemeClr val="accent1"/>
+          </a:lnRef>
+          <a:fillRef idx="0">
+            <a:schemeClr val="accent1"/>
+          </a:fillRef>
+          <a:effectRef idx="0">
+            <a:schemeClr val="accent1"/>
+          </a:effectRef>
+          <a:fontRef idx="minor">
+            <a:schemeClr val="tx1"/>
+          </a:fontRef>
+        </p:style>
+      </p:cxnSp>
+      <p:sp>
+        <p:nvSpPr>
+          <p:cNvPr id="8" name="TextBox 7">
+            <a:extLst>
+              <a:ext uri="{FF2B5EF4-FFF2-40B4-BE49-F238E27FC236}">
+                <a16:creationId xmlns:a16="http://schemas.microsoft.com/office/drawing/2014/main" id="{3B924128-5302-FCE2-9E14-2688B1DCEC91}"/>
+              </a:ext>
+            </a:extLst>
+          </p:cNvPr>
+          <p:cNvSpPr txBox="1"/>
+          <p:nvPr/>
+        </p:nvSpPr>
+        <p:spPr>
+          <a:xfrm>
+            <a:off x="55365" y="3729792"/>
+            <a:ext cx="301686" cy="369332"/>
+          </a:xfrm>
+          <a:prstGeom prst="rect">
+            <a:avLst/>
+          </a:prstGeom>
+          <a:noFill/>
+        </p:spPr>
+        <p:txBody>
+          <a:bodyPr wrap="none" rtlCol="0">
+            <a:spAutoFit/>
+          </a:bodyPr>
+          <a:lstStyle/>
+          <a:p>
+            <a:r>
+              <a:rPr lang="en-US" dirty="0">
+                <a:solidFill>
+                  <a:schemeClr val="bg1"/>
+                </a:solidFill>
+              </a:rPr>
+              <a:t>2</a:t>
+            </a:r>
+          </a:p>
+        </p:txBody>
+      </p:sp>
+      <p:cxnSp>
+        <p:nvCxnSpPr>
+          <p:cNvPr id="9" name="Straight Arrow Connector 8">
+            <a:extLst>
+              <a:ext uri="{FF2B5EF4-FFF2-40B4-BE49-F238E27FC236}">
+                <a16:creationId xmlns:a16="http://schemas.microsoft.com/office/drawing/2014/main" id="{B613A718-F71B-6BAF-DDFB-D7F4B1579900}"/>
+              </a:ext>
+            </a:extLst>
+          </p:cNvPr>
+          <p:cNvCxnSpPr>
+            <a:cxnSpLocks/>
+          </p:cNvCxnSpPr>
+          <p:nvPr/>
+        </p:nvCxnSpPr>
+        <p:spPr>
+          <a:xfrm>
+            <a:off x="357051" y="5660959"/>
+            <a:ext cx="452846" cy="329891"/>
+          </a:xfrm>
+          <a:prstGeom prst="straightConnector1">
+            <a:avLst/>
+          </a:prstGeom>
+          <a:ln>
+            <a:solidFill>
+              <a:schemeClr val="bg1"/>
+            </a:solidFill>
+            <a:tailEnd type="triangle"/>
+          </a:ln>
+        </p:spPr>
+        <p:style>
+          <a:lnRef idx="1">
+            <a:schemeClr val="accent1"/>
+          </a:lnRef>
+          <a:fillRef idx="0">
+            <a:schemeClr val="accent1"/>
+          </a:fillRef>
+          <a:effectRef idx="0">
+            <a:schemeClr val="accent1"/>
+          </a:effectRef>
+          <a:fontRef idx="minor">
+            <a:schemeClr val="tx1"/>
+          </a:fontRef>
+        </p:style>
+      </p:cxnSp>
+      <p:cxnSp>
+        <p:nvCxnSpPr>
+          <p:cNvPr id="10" name="Straight Arrow Connector 9">
+            <a:extLst>
+              <a:ext uri="{FF2B5EF4-FFF2-40B4-BE49-F238E27FC236}">
+                <a16:creationId xmlns:a16="http://schemas.microsoft.com/office/drawing/2014/main" id="{5BF1F71E-127A-64C7-3040-4A180D49E507}"/>
+              </a:ext>
+            </a:extLst>
+          </p:cNvPr>
+          <p:cNvCxnSpPr/>
+          <p:nvPr/>
+        </p:nvCxnSpPr>
+        <p:spPr>
+          <a:xfrm flipV="1">
+            <a:off x="357051" y="5272691"/>
+            <a:ext cx="452846" cy="288119"/>
+          </a:xfrm>
+          <a:prstGeom prst="straightConnector1">
+            <a:avLst/>
+          </a:prstGeom>
+          <a:ln>
+            <a:solidFill>
+              <a:schemeClr val="bg1"/>
+            </a:solidFill>
+            <a:tailEnd type="triangle"/>
+          </a:ln>
+        </p:spPr>
+        <p:style>
+          <a:lnRef idx="1">
+            <a:schemeClr val="accent1"/>
+          </a:lnRef>
+          <a:fillRef idx="0">
+            <a:schemeClr val="accent1"/>
+          </a:fillRef>
+          <a:effectRef idx="0">
+            <a:schemeClr val="accent1"/>
+          </a:effectRef>
+          <a:fontRef idx="minor">
+            <a:schemeClr val="tx1"/>
+          </a:fontRef>
+        </p:style>
+      </p:cxnSp>
+      <p:sp>
+        <p:nvSpPr>
+          <p:cNvPr id="11" name="TextBox 10">
+            <a:extLst>
+              <a:ext uri="{FF2B5EF4-FFF2-40B4-BE49-F238E27FC236}">
+                <a16:creationId xmlns:a16="http://schemas.microsoft.com/office/drawing/2014/main" id="{91BF082C-D166-3D67-9240-ED10060FB6BE}"/>
+              </a:ext>
+            </a:extLst>
+          </p:cNvPr>
+          <p:cNvSpPr txBox="1"/>
+          <p:nvPr/>
+        </p:nvSpPr>
+        <p:spPr>
+          <a:xfrm>
+            <a:off x="55365" y="5411001"/>
+            <a:ext cx="301686" cy="369332"/>
+          </a:xfrm>
+          <a:prstGeom prst="rect">
+            <a:avLst/>
+          </a:prstGeom>
+          <a:noFill/>
+        </p:spPr>
+        <p:txBody>
+          <a:bodyPr wrap="none" rtlCol="0">
+            <a:spAutoFit/>
+          </a:bodyPr>
+          <a:lstStyle/>
+          <a:p>
+            <a:r>
+              <a:rPr lang="en-US" dirty="0">
+                <a:solidFill>
+                  <a:schemeClr val="bg1"/>
+                </a:solidFill>
+              </a:rPr>
+              <a:t>3</a:t>
             </a:r>
           </a:p>
         </p:txBody>

</xml_diff>